<commit_message>
Sync: vault flow-through from today's run
What node sync.mjs picked up beyond the library work: the 19 Media
Studies decks were regenerated larger in the vault (deck download lines
track the new sizes, credits refreshed), and lessons 13, 14 and 17 came
back through the reframe with fresh cache entries.

Co-Authored-By: Claude Fable 5 <noreply@anthropic.com>
</commit_message>
<xml_diff>
--- a/content/decks/media-studies/media-studies-s1-lesson-11-representation-applied-to-your-own-product.pptx
+++ b/content/decks/media-studies/media-studies-s1-lesson-11-representation-applied-to-your-own-product.pptx
@@ -17,9 +17,10 @@
     <p:sldId id="265" r:id="rId11"/>
     <p:sldId id="266" r:id="rId12"/>
     <p:sldId id="267" r:id="rId13"/>
+    <p:sldId id="268" r:id="rId14"/>
   </p:sldIdLst>
   <p:notesMasterIdLst>
-    <p:notesMasterId r:id="rId14"/>
+    <p:notesMasterId r:id="rId15"/>
   </p:notesMasterIdLst>
   <p:sldSz cx="12192000" cy="6858000"/>
   <p:notesSz cx="6858000" cy="12192000"/>
@@ -601,7 +602,7 @@
           <a:p>
             <a:r>
               <a:rPr lang="en-US" dirty="0"/>
-              <a:t/>
+              <a:t>D3's case pair stays PROPOSED: one British TV stereotype, one Hollywood film stereotype, both exam-eligible, worked in groups with Hall's positions run across both. Deck U3.2 is the ready-made Hall lesson if wanted.</a:t>
             </a:r>
             <a:endParaRPr lang="en-US" dirty="0"/>
           </a:p>
@@ -689,7 +690,7 @@
           <a:p>
             <a:r>
               <a:rPr lang="en-US" dirty="0"/>
-              <a:t/>
+              <a:t>An international text the room meets again at L10 as the enigma frame; here the same still carries Hall's absence. The absence inventory then runs on one text and on their own C1 planning.</a:t>
             </a:r>
             <a:endParaRPr lang="en-US" dirty="0"/>
           </a:p>
@@ -777,7 +778,7 @@
           <a:p>
             <a:r>
               <a:rPr lang="en-US" dirty="0"/>
-              <a:t/>
+              <a:t>D5 screening conditions: no introductions, no apologies, no pausing; response cards completed while watching and handed to makers unread by anyone else. D6 converts findings to production pickups with dates; LB3 posted.</a:t>
             </a:r>
             <a:endParaRPr lang="en-US" dirty="0"/>
           </a:p>
@@ -801,6 +802,94 @@
             <a:fld id="{F7021451-1387-4CA6-816F-3879F97B5CBC}" type="slidenum">
               <a:rPr lang="en-US"/>
               <a:t>12</a:t>
+            </a:fld>
+            <a:endParaRPr lang="en-US"/>
+          </a:p>
+        </p:txBody>
+      </p:sp>
+    </p:spTree>
+    <p:extLst>
+      <p:ext uri="{BB962C8B-B14F-4D97-AF65-F5344CB8AC3E}">
+        <p14:creationId xmlns:p14="http://schemas.microsoft.com/office/powerpoint/2010/main" val="1024086991"/>
+      </p:ext>
+    </p:extLst>
+  </p:cSld>
+  <p:clrMapOvr>
+    <a:masterClrMapping/>
+  </p:clrMapOvr>
+</p:notes>
+</file>
+
+<file path=ppt/notesSlides/notesSlide13.xml><?xml version="1.0" encoding="utf-8"?>
+<p:notes xmlns:a="http://schemas.openxmlformats.org/drawingml/2006/main" xmlns:r="http://schemas.openxmlformats.org/officeDocument/2006/relationships" xmlns:p="http://schemas.openxmlformats.org/presentationml/2006/main">
+  <p:cSld>
+    <p:spTree>
+      <p:nvGrpSpPr>
+        <p:cNvPr id="1" name=""/>
+        <p:cNvGrpSpPr/>
+        <p:nvPr/>
+      </p:nvGrpSpPr>
+      <p:grpSpPr>
+        <a:xfrm>
+          <a:off x="0" y="0"/>
+          <a:ext cx="0" cy="0"/>
+          <a:chOff x="0" y="0"/>
+          <a:chExt cx="0" cy="0"/>
+        </a:xfrm>
+      </p:grpSpPr>
+      <p:sp>
+        <p:nvSpPr>
+          <p:cNvPr id="2" name="Slide Image Placeholder 1"/>
+          <p:cNvSpPr>
+            <a:spLocks noGrp="1" noRot="1" noChangeAspect="1"/>
+          </p:cNvSpPr>
+          <p:nvPr>
+            <p:ph type="sldImg"/>
+          </p:nvPr>
+        </p:nvSpPr>
+        <p:spPr/>
+      </p:sp>
+      <p:sp>
+        <p:nvSpPr>
+          <p:cNvPr id="3" name="Notes Placeholder 2"/>
+          <p:cNvSpPr>
+            <a:spLocks noGrp="1"/>
+          </p:cNvSpPr>
+          <p:nvPr>
+            <p:ph type="body" idx="1"/>
+          </p:nvPr>
+        </p:nvSpPr>
+        <p:spPr/>
+        <p:txBody>
+          <a:bodyPr/>
+          <a:lstStyle/>
+          <a:p>
+            <a:r>
+              <a:rPr lang="en-US" dirty="0"/>
+              <a:t/>
+            </a:r>
+            <a:endParaRPr lang="en-US" dirty="0"/>
+          </a:p>
+        </p:txBody>
+      </p:sp>
+      <p:sp>
+        <p:nvSpPr>
+          <p:cNvPr id="4" name="Slide Number Placeholder 3"/>
+          <p:cNvSpPr>
+            <a:spLocks noGrp="1"/>
+          </p:cNvSpPr>
+          <p:nvPr>
+            <p:ph type="sldNum" sz="quarter" idx="10"/>
+          </p:nvPr>
+        </p:nvSpPr>
+        <p:spPr/>
+        <p:txBody>
+          <a:bodyPr/>
+          <a:lstStyle/>
+          <a:p>
+            <a:fld id="{F7021451-1387-4CA6-816F-3879F97B5CBC}" type="slidenum">
+              <a:rPr lang="en-US"/>
+              <a:t>13</a:t>
             </a:fld>
             <a:endParaRPr lang="en-US"/>
           </a:p>
@@ -1129,7 +1218,7 @@
           <a:p>
             <a:r>
               <a:rPr lang="en-US" dirty="0"/>
-              <a:t/>
+              <a:t>Coursebook 3.3's own phrase: never objective. The same-person-three-ways exercise (official portrait, news photo, fan edit of one figure the room knows) runs live after this; choosing the figure stays a classroom decision, per the plan's caution against active PRC political figures.</a:t>
             </a:r>
             <a:endParaRPr lang="en-US" dirty="0"/>
           </a:p>
@@ -1217,7 +1306,7 @@
           <a:p>
             <a:r>
               <a:rPr lang="en-US" dirty="0"/>
-              <a:t/>
+              <a:t>One shared text on screen for the corners; a Downton frame from the next slide serves twice. Theory card: Hall.</a:t>
             </a:r>
             <a:endParaRPr lang="en-US" dirty="0"/>
           </a:p>
@@ -1481,7 +1570,7 @@
           <a:p>
             <a:r>
               <a:rPr lang="en-US" dirty="0"/>
-              <a:t/>
+              <a:t>D3's 25-minute block, previously slide-less. The coursebook's own-country prompt closes the block as a short spoken aside, as contrast, never as the written outcome, per the exam-example rule.</a:t>
             </a:r>
             <a:endParaRPr lang="en-US" dirty="0"/>
           </a:p>
@@ -2109,7 +2198,7 @@
     <p:bg>
       <p:bgPr>
         <a:solidFill>
-          <a:srgbClr val="E8EFE7"/>
+          <a:srgbClr val="FAF8F1"/>
         </a:solidFill>
       </p:bgPr>
     </p:bg>
@@ -2135,108 +2224,147 @@
         </p:nvSpPr>
         <p:spPr>
           <a:xfrm>
-            <a:off x="502920" y="548640"/>
-            <a:ext cx="1828800" cy="1828800"/>
-          </a:xfrm>
-          <a:prstGeom prst="rect">
-            <a:avLst/>
-          </a:prstGeom>
-          <a:noFill/>
-          <a:ln/>
-        </p:spPr>
-        <p:txBody>
-          <a:bodyPr wrap="square" lIns="0" tIns="0" rIns="0" bIns="0" rtlCol="0" anchor="t"/>
+            <a:off x="822960" y="457200"/>
+            <a:ext cx="6400800" cy="274320"/>
+          </a:xfrm>
+          <a:prstGeom prst="rect">
+            <a:avLst/>
+          </a:prstGeom>
+          <a:noFill/>
+          <a:ln/>
+        </p:spPr>
+        <p:txBody>
+          <a:bodyPr wrap="square" lIns="0" tIns="0" rIns="0" bIns="0" rtlCol="0" anchor="ctr"/>
+          <a:lstStyle/>
+          <a:p>
+            <a:pPr algn="l" indent="0" marL="0">
+              <a:buNone/>
+            </a:pPr>
+            <a:r>
+              <a:rPr lang="en-US" sz="1100" b="1" spc="250" kern="0" dirty="0">
+                <a:solidFill>
+                  <a:srgbClr val="4A6B5D"/>
+                </a:solidFill>
+                <a:latin typeface="Arial" pitchFamily="34" charset="0"/>
+                <a:ea typeface="Arial" pitchFamily="34" charset="-122"/>
+                <a:cs typeface="Arial" pitchFamily="34" charset="-120"/>
+              </a:rPr>
+              <a:t>STEREOTYPING AS POWER</a:t>
+            </a:r>
+            <a:endParaRPr lang="en-US" sz="1100" dirty="0"/>
+          </a:p>
+        </p:txBody>
+      </p:sp>
+      <p:sp>
+        <p:nvSpPr>
+          <p:cNvPr id="3" name="Text 1"/>
+          <p:cNvSpPr/>
+          <p:nvPr/>
+        </p:nvSpPr>
+        <p:spPr>
+          <a:xfrm>
+            <a:off x="6793992" y="457200"/>
+            <a:ext cx="4572000" cy="274320"/>
+          </a:xfrm>
+          <a:prstGeom prst="rect">
+            <a:avLst/>
+          </a:prstGeom>
+          <a:noFill/>
+          <a:ln/>
+        </p:spPr>
+        <p:txBody>
+          <a:bodyPr wrap="square" lIns="0" tIns="0" rIns="0" bIns="0" rtlCol="0" anchor="ctr"/>
+          <a:lstStyle/>
+          <a:p>
+            <a:pPr algn="r" indent="0" marL="0">
+              <a:buNone/>
+            </a:pPr>
+            <a:r>
+              <a:rPr lang="en-US" sz="1100" b="1" spc="250" kern="0" dirty="0">
+                <a:solidFill>
+                  <a:srgbClr val="7A7F72"/>
+                </a:solidFill>
+                <a:latin typeface="Arial" pitchFamily="34" charset="0"/>
+                <a:ea typeface="Arial" pitchFamily="34" charset="-122"/>
+                <a:cs typeface="Arial" pitchFamily="34" charset="-120"/>
+              </a:rPr>
+              <a:t>WHO BENEFITS, WHO PAYS</a:t>
+            </a:r>
+            <a:endParaRPr lang="en-US" sz="1100" dirty="0"/>
+          </a:p>
+        </p:txBody>
+      </p:sp>
+      <p:sp>
+        <p:nvSpPr>
+          <p:cNvPr id="4" name="Shape 2"/>
+          <p:cNvSpPr/>
+          <p:nvPr/>
+        </p:nvSpPr>
+        <p:spPr>
+          <a:xfrm>
+            <a:off x="822960" y="786384"/>
+            <a:ext cx="10543032" cy="0"/>
+          </a:xfrm>
+          <a:prstGeom prst="line">
+            <a:avLst/>
+          </a:prstGeom>
+          <a:noFill/>
+          <a:ln w="9525">
+            <a:solidFill>
+              <a:srgbClr val="D9D4C4"/>
+            </a:solidFill>
+            <a:prstDash val="solid"/>
+          </a:ln>
+        </p:spPr>
+      </p:sp>
+      <p:sp>
+        <p:nvSpPr>
+          <p:cNvPr id="5" name="Text 3"/>
+          <p:cNvSpPr/>
+          <p:nvPr/>
+        </p:nvSpPr>
+        <p:spPr>
+          <a:xfrm>
+            <a:off x="822960" y="1051560"/>
+            <a:ext cx="6400800" cy="822960"/>
+          </a:xfrm>
+          <a:prstGeom prst="rect">
+            <a:avLst/>
+          </a:prstGeom>
+          <a:noFill/>
+          <a:ln/>
+        </p:spPr>
+        <p:txBody>
+          <a:bodyPr wrap="square" lIns="0" tIns="0" rIns="0" bIns="0" rtlCol="0" anchor="ctr"/>
           <a:lstStyle/>
           <a:p>
             <a:pPr indent="0" marL="0">
               <a:buNone/>
             </a:pPr>
             <a:r>
-              <a:rPr lang="en-US" sz="20000" dirty="0">
-                <a:solidFill>
-                  <a:srgbClr val="A3C1AD"/>
+              <a:rPr lang="en-US" sz="3200" dirty="0">
+                <a:solidFill>
+                  <a:srgbClr val="24313F"/>
                 </a:solidFill>
                 <a:latin typeface="Georgia" pitchFamily="34" charset="0"/>
                 <a:ea typeface="Georgia" pitchFamily="34" charset="-122"/>
                 <a:cs typeface="Georgia" pitchFamily="34" charset="-120"/>
               </a:rPr>
-              <a:t>“</a:t>
-            </a:r>
-            <a:endParaRPr lang="en-US" sz="20000" dirty="0"/>
-          </a:p>
-        </p:txBody>
-      </p:sp>
-      <p:sp>
-        <p:nvSpPr>
-          <p:cNvPr id="3" name="Text 1"/>
-          <p:cNvSpPr/>
-          <p:nvPr/>
-        </p:nvSpPr>
-        <p:spPr>
-          <a:xfrm>
-            <a:off x="822960" y="1920240"/>
-            <a:ext cx="10424160" cy="2194560"/>
-          </a:xfrm>
-          <a:prstGeom prst="rect">
-            <a:avLst/>
-          </a:prstGeom>
-          <a:noFill/>
-          <a:ln/>
-        </p:spPr>
-        <p:txBody>
-          <a:bodyPr wrap="square" lIns="0" tIns="0" rIns="0" bIns="0" rtlCol="0" anchor="ctr"/>
-          <a:lstStyle/>
-          <a:p>
-            <a:pPr indent="0" marL="0">
-              <a:lnSpc>
-                <a:spcPts val="5000"/>
-              </a:lnSpc>
-              <a:buNone/>
-            </a:pPr>
-            <a:r>
-              <a:rPr lang="en-US" sz="4200" dirty="0">
-                <a:solidFill>
-                  <a:srgbClr val="24313F"/>
-                </a:solidFill>
-                <a:latin typeface="Georgia" pitchFamily="34" charset="0"/>
-                <a:ea typeface="Georgia" pitchFamily="34" charset="-122"/>
-                <a:cs typeface="Georgia" pitchFamily="34" charset="-120"/>
-              </a:rPr>
-              <a:t>What is never in the frame</a:t>
-            </a:r>
-            <a:endParaRPr lang="en-US" sz="4200" dirty="0"/>
-          </a:p>
-          <a:p>
-            <a:pPr indent="0" marL="0">
-              <a:lnSpc>
-                <a:spcPts val="5000"/>
-              </a:lnSpc>
-              <a:buNone/>
-            </a:pPr>
-            <a:r>
-              <a:rPr lang="en-US" sz="4200" dirty="0">
-                <a:solidFill>
-                  <a:srgbClr val="24313F"/>
-                </a:solidFill>
-                <a:latin typeface="Georgia" pitchFamily="34" charset="0"/>
-                <a:ea typeface="Georgia" pitchFamily="34" charset="-122"/>
-                <a:cs typeface="Georgia" pitchFamily="34" charset="-120"/>
-              </a:rPr>
-              <a:t>cannot be argued with.</a:t>
-            </a:r>
-            <a:endParaRPr lang="en-US" sz="4200" dirty="0"/>
-          </a:p>
-        </p:txBody>
-      </p:sp>
-      <p:sp>
-        <p:nvSpPr>
-          <p:cNvPr id="4" name="Shape 2"/>
-          <p:cNvSpPr/>
-          <p:nvPr/>
-        </p:nvSpPr>
-        <p:spPr>
-          <a:xfrm>
-            <a:off x="822960" y="4663440"/>
+              <a:t>A shortcut with a beneficiary</a:t>
+            </a:r>
+            <a:endParaRPr lang="en-US" sz="3200" dirty="0"/>
+          </a:p>
+        </p:txBody>
+      </p:sp>
+      <p:sp>
+        <p:nvSpPr>
+          <p:cNvPr id="6" name="Shape 4"/>
+          <p:cNvSpPr/>
+          <p:nvPr/>
+        </p:nvSpPr>
+        <p:spPr>
+          <a:xfrm>
+            <a:off x="822960" y="2057400"/>
             <a:ext cx="914400" cy="0"/>
           </a:xfrm>
           <a:prstGeom prst="line">
@@ -2253,40 +2381,264 @@
       </p:sp>
       <p:sp>
         <p:nvSpPr>
-          <p:cNvPr id="5" name="Text 3"/>
-          <p:cNvSpPr/>
-          <p:nvPr/>
-        </p:nvSpPr>
-        <p:spPr>
-          <a:xfrm>
-            <a:off x="822960" y="4846320"/>
-            <a:ext cx="10241280" cy="457200"/>
-          </a:xfrm>
-          <a:prstGeom prst="rect">
-            <a:avLst/>
-          </a:prstGeom>
-          <a:noFill/>
-          <a:ln/>
-        </p:spPr>
-        <p:txBody>
-          <a:bodyPr wrap="square" lIns="0" tIns="0" rIns="0" bIns="0" rtlCol="0" anchor="ctr"/>
+          <p:cNvPr id="7" name="Text 5"/>
+          <p:cNvSpPr/>
+          <p:nvPr/>
+        </p:nvSpPr>
+        <p:spPr>
+          <a:xfrm>
+            <a:off x="822960" y="2286000"/>
+            <a:ext cx="6400800" cy="3291840"/>
+          </a:xfrm>
+          <a:prstGeom prst="rect">
+            <a:avLst/>
+          </a:prstGeom>
+          <a:noFill/>
+          <a:ln/>
+        </p:spPr>
+        <p:txBody>
+          <a:bodyPr wrap="square" lIns="0" tIns="0" rIns="0" bIns="0" rtlCol="0" anchor="t"/>
           <a:lstStyle/>
           <a:p>
             <a:pPr indent="0" marL="0">
-              <a:buNone/>
-            </a:pPr>
-            <a:r>
-              <a:rPr lang="en-US" sz="1400" spc="100" kern="0" dirty="0">
-                <a:solidFill>
-                  <a:srgbClr val="4A6B5D"/>
+              <a:lnSpc>
+                <a:spcPts val="2400"/>
+              </a:lnSpc>
+              <a:buNone/>
+            </a:pPr>
+            <a:r>
+              <a:rPr lang="en-US" sz="1700" dirty="0">
+                <a:solidFill>
+                  <a:srgbClr val="24313F"/>
+                </a:solidFill>
+                <a:latin typeface="Georgia" pitchFamily="34" charset="0"/>
+                <a:ea typeface="Georgia" pitchFamily="34" charset="-122"/>
+                <a:cs typeface="Georgia" pitchFamily="34" charset="-120"/>
+              </a:rPr>
+              <a:t>A stereotype is not a lie. It is a shortcut, and every shortcut has a beneficiary and someone who pays the toll. Ask both questions of every case: who is served by this being the quick version, and who is cost by it?</a:t>
+            </a:r>
+            <a:endParaRPr lang="en-US" sz="1700" dirty="0"/>
+          </a:p>
+          <a:p>
+            <a:pPr indent="0" marL="0">
+              <a:lnSpc>
+                <a:spcPts val="2400"/>
+              </a:lnSpc>
+              <a:buNone/>
+            </a:pPr>
+            <a:endParaRPr lang="en-US" sz="1700" dirty="0"/>
+          </a:p>
+          <a:p>
+            <a:pPr indent="0" marL="0">
+              <a:lnSpc>
+                <a:spcPts val="2400"/>
+              </a:lnSpc>
+              <a:buNone/>
+            </a:pPr>
+            <a:r>
+              <a:rPr lang="en-US" sz="1700" dirty="0">
+                <a:solidFill>
+                  <a:srgbClr val="24313F"/>
+                </a:solidFill>
+                <a:latin typeface="Georgia" pitchFamily="34" charset="0"/>
+                <a:ea typeface="Georgia" pitchFamily="34" charset="-122"/>
+                <a:cs typeface="Georgia" pitchFamily="34" charset="-120"/>
+              </a:rPr>
+              <a:t>A counter-stereotype registers as surprising only because the shortcut is so well worn: a grieving old man as an action hero surprises exactly once, and the surprise is the evidence.</a:t>
+            </a:r>
+            <a:endParaRPr lang="en-US" sz="1700" dirty="0"/>
+          </a:p>
+        </p:txBody>
+      </p:sp>
+      <p:sp>
+        <p:nvSpPr>
+          <p:cNvPr id="8" name="Shape 6"/>
+          <p:cNvSpPr/>
+          <p:nvPr/>
+        </p:nvSpPr>
+        <p:spPr>
+          <a:xfrm>
+            <a:off x="7589520" y="1188720"/>
+            <a:ext cx="3794760" cy="4023360"/>
+          </a:xfrm>
+          <a:prstGeom prst="rect">
+            <a:avLst/>
+          </a:prstGeom>
+          <a:solidFill>
+            <a:srgbClr val="FAF8F1"/>
+          </a:solidFill>
+          <a:ln w="9525">
+            <a:solidFill>
+              <a:srgbClr val="D9D4C4"/>
+            </a:solidFill>
+            <a:prstDash val="solid"/>
+          </a:ln>
+        </p:spPr>
+      </p:sp>
+      <p:pic>
+        <p:nvPicPr>
+          <p:cNvPr id="9" name="Image 0" descr="/Users/dogan/Documents/Vaults/Courses/wiki/classes/media-studies/decks/_build/img/up-carl.jpg">    </p:cNvPr>
+          <p:cNvPicPr>
+            <a:picLocks noChangeAspect="1"/>
+          </p:cNvPicPr>
+          <p:nvPr/>
+        </p:nvPicPr>
+        <p:blipFill>
+          <a:blip r:embed="rId1"/>
+          <a:stretch>
+            <a:fillRect/>
+          </a:stretch>
+        </p:blipFill>
+        <p:spPr>
+          <a:xfrm>
+            <a:off x="7717536" y="2205133"/>
+            <a:ext cx="3538728" cy="1990535"/>
+          </a:xfrm>
+          <a:prstGeom prst="rect">
+            <a:avLst/>
+          </a:prstGeom>
+        </p:spPr>
+      </p:pic>
+      <p:sp>
+        <p:nvSpPr>
+          <p:cNvPr id="10" name="Text 7"/>
+          <p:cNvSpPr/>
+          <p:nvPr/>
+        </p:nvSpPr>
+        <p:spPr>
+          <a:xfrm>
+            <a:off x="7589520" y="5257800"/>
+            <a:ext cx="3794760" cy="457200"/>
+          </a:xfrm>
+          <a:prstGeom prst="rect">
+            <a:avLst/>
+          </a:prstGeom>
+          <a:noFill/>
+          <a:ln/>
+        </p:spPr>
+        <p:txBody>
+          <a:bodyPr wrap="square" lIns="0" tIns="0" rIns="0" bIns="0" rtlCol="0" anchor="t"/>
+          <a:lstStyle/>
+          <a:p>
+            <a:pPr algn="ctr" indent="0" marL="0">
+              <a:lnSpc>
+                <a:spcPts val="1300"/>
+              </a:lnSpc>
+              <a:buNone/>
+            </a:pPr>
+            <a:r>
+              <a:rPr lang="en-US" sz="1000" dirty="0">
+                <a:solidFill>
+                  <a:srgbClr val="7A7F72"/>
                 </a:solidFill>
                 <a:latin typeface="Arial" pitchFamily="34" charset="0"/>
                 <a:ea typeface="Arial" pitchFamily="34" charset="-122"/>
                 <a:cs typeface="Arial" pitchFamily="34" charset="-120"/>
               </a:rPr>
-              <a:t>Who never appears cannot complain. Run the inventory on your own product: who is missing, and did you choose that or default to it?</a:t>
-            </a:r>
-            <a:endParaRPr lang="en-US" sz="1400" dirty="0"/>
+              <a:t>UP (2009, Pixar): Carl, the coursebook's own counter-stereotype</a:t>
+            </a:r>
+            <a:endParaRPr lang="en-US" sz="1000" dirty="0"/>
+          </a:p>
+        </p:txBody>
+      </p:sp>
+      <p:sp>
+        <p:nvSpPr>
+          <p:cNvPr id="11" name="Shape 8"/>
+          <p:cNvSpPr/>
+          <p:nvPr/>
+        </p:nvSpPr>
+        <p:spPr>
+          <a:xfrm>
+            <a:off x="822960" y="6382512"/>
+            <a:ext cx="10543032" cy="0"/>
+          </a:xfrm>
+          <a:prstGeom prst="line">
+            <a:avLst/>
+          </a:prstGeom>
+          <a:noFill/>
+          <a:ln w="9525">
+            <a:solidFill>
+              <a:srgbClr val="D9D4C4"/>
+            </a:solidFill>
+            <a:prstDash val="solid"/>
+          </a:ln>
+        </p:spPr>
+      </p:sp>
+      <p:sp>
+        <p:nvSpPr>
+          <p:cNvPr id="12" name="Text 9"/>
+          <p:cNvSpPr/>
+          <p:nvPr/>
+        </p:nvSpPr>
+        <p:spPr>
+          <a:xfrm>
+            <a:off x="822960" y="6419088"/>
+            <a:ext cx="7315200" cy="274320"/>
+          </a:xfrm>
+          <a:prstGeom prst="rect">
+            <a:avLst/>
+          </a:prstGeom>
+          <a:noFill/>
+          <a:ln/>
+        </p:spPr>
+        <p:txBody>
+          <a:bodyPr wrap="square" lIns="0" tIns="0" rIns="0" bIns="0" rtlCol="0" anchor="ctr"/>
+          <a:lstStyle/>
+          <a:p>
+            <a:pPr indent="0" marL="0">
+              <a:buNone/>
+            </a:pPr>
+            <a:r>
+              <a:rPr lang="en-US" sz="900" spc="150" kern="0" dirty="0">
+                <a:solidFill>
+                  <a:srgbClr val="7A7F72"/>
+                </a:solidFill>
+                <a:latin typeface="Arial" pitchFamily="34" charset="0"/>
+                <a:ea typeface="Arial" pitchFamily="34" charset="-122"/>
+                <a:cs typeface="Arial" pitchFamily="34" charset="-120"/>
+              </a:rPr>
+              <a:t>MEDIA STUDIES 9607 · SEMESTER I</a:t>
+            </a:r>
+            <a:endParaRPr lang="en-US" sz="900" dirty="0"/>
+          </a:p>
+        </p:txBody>
+      </p:sp>
+      <p:sp>
+        <p:nvSpPr>
+          <p:cNvPr id="13" name="Text 10"/>
+          <p:cNvSpPr/>
+          <p:nvPr/>
+        </p:nvSpPr>
+        <p:spPr>
+          <a:xfrm>
+            <a:off x="10268712" y="6355080"/>
+            <a:ext cx="1097280" cy="365760"/>
+          </a:xfrm>
+          <a:prstGeom prst="rect">
+            <a:avLst/>
+          </a:prstGeom>
+          <a:noFill/>
+          <a:ln/>
+        </p:spPr>
+        <p:txBody>
+          <a:bodyPr wrap="square" lIns="0" tIns="0" rIns="0" bIns="0" rtlCol="0" anchor="ctr"/>
+          <a:lstStyle/>
+          <a:p>
+            <a:pPr algn="r" indent="0" marL="0">
+              <a:buNone/>
+            </a:pPr>
+            <a:r>
+              <a:rPr lang="en-US" sz="1600" dirty="0">
+                <a:solidFill>
+                  <a:srgbClr val="A3C1AD"/>
+                </a:solidFill>
+                <a:latin typeface="Georgia" pitchFamily="34" charset="0"/>
+                <a:ea typeface="Georgia" pitchFamily="34" charset="-122"/>
+                <a:cs typeface="Georgia" pitchFamily="34" charset="-120"/>
+              </a:rPr>
+              <a:t>04</a:t>
+            </a:r>
+            <a:endParaRPr lang="en-US" sz="1600" dirty="0"/>
           </a:p>
         </p:txBody>
       </p:sp>
@@ -2355,7 +2707,7 @@
                 <a:ea typeface="Arial" pitchFamily="34" charset="-122"/>
                 <a:cs typeface="Arial" pitchFamily="34" charset="-120"/>
               </a:rPr>
-              <a:t>THE SELF-AUDIT</a:t>
+              <a:t>ABSENCE</a:t>
             </a:r>
             <a:endParaRPr lang="en-US" sz="1100" dirty="0"/>
           </a:p>
@@ -2394,7 +2746,7 @@
                 <a:ea typeface="Arial" pitchFamily="34" charset="-122"/>
                 <a:cs typeface="Arial" pitchFamily="34" charset="-120"/>
               </a:rPr>
-              <a:t>THE WEEK'S FULL TOOLKIT, ON YOUR OWN CUT</a:t>
+              <a:t>SELECTIVE CONSTRUCTION'S QUIETEST TOOL</a:t>
             </a:r>
             <a:endParaRPr lang="en-US" sz="1100" dirty="0"/>
           </a:p>
@@ -2425,577 +2777,21 @@
       </p:sp>
       <p:sp>
         <p:nvSpPr>
-          <p:cNvPr id="5" name="Text 3"/>
-          <p:cNvSpPr/>
-          <p:nvPr/>
-        </p:nvSpPr>
-        <p:spPr>
-          <a:xfrm>
-            <a:off x="822960" y="932688"/>
-            <a:ext cx="10543032" cy="640080"/>
-          </a:xfrm>
-          <a:prstGeom prst="rect">
-            <a:avLst/>
-          </a:prstGeom>
-          <a:noFill/>
-          <a:ln/>
-        </p:spPr>
-        <p:txBody>
-          <a:bodyPr wrap="square" lIns="0" tIns="0" rIns="0" bIns="0" rtlCol="0" anchor="ctr"/>
-          <a:lstStyle/>
-          <a:p>
-            <a:pPr indent="0" marL="0">
-              <a:buNone/>
-            </a:pPr>
-            <a:r>
-              <a:rPr lang="en-US" sz="3000" dirty="0">
-                <a:solidFill>
-                  <a:srgbClr val="24313F"/>
-                </a:solidFill>
-                <a:latin typeface="Georgia" pitchFamily="34" charset="0"/>
-                <a:ea typeface="Georgia" pitchFamily="34" charset="-122"/>
-                <a:cs typeface="Georgia" pitchFamily="34" charset="-120"/>
-              </a:rPr>
-              <a:t>Four questions of your own product</a:t>
-            </a:r>
-            <a:endParaRPr lang="en-US" sz="3000" dirty="0"/>
-          </a:p>
-        </p:txBody>
-      </p:sp>
-      <p:sp>
-        <p:nvSpPr>
-          <p:cNvPr id="6" name="Text 4"/>
-          <p:cNvSpPr/>
-          <p:nvPr/>
-        </p:nvSpPr>
-        <p:spPr>
-          <a:xfrm>
-            <a:off x="822960" y="1920240"/>
-            <a:ext cx="914400" cy="548640"/>
-          </a:xfrm>
-          <a:prstGeom prst="rect">
-            <a:avLst/>
-          </a:prstGeom>
-          <a:noFill/>
-          <a:ln/>
-        </p:spPr>
-        <p:txBody>
-          <a:bodyPr wrap="square" lIns="0" tIns="0" rIns="0" bIns="0" rtlCol="0" anchor="ctr"/>
-          <a:lstStyle/>
-          <a:p>
-            <a:pPr indent="0" marL="0">
-              <a:buNone/>
-            </a:pPr>
-            <a:r>
-              <a:rPr lang="en-US" sz="3000" dirty="0">
-                <a:solidFill>
-                  <a:srgbClr val="A3C1AD"/>
-                </a:solidFill>
-                <a:latin typeface="Georgia" pitchFamily="34" charset="0"/>
-                <a:ea typeface="Georgia" pitchFamily="34" charset="-122"/>
-                <a:cs typeface="Georgia" pitchFamily="34" charset="-120"/>
-              </a:rPr>
-              <a:t>01</a:t>
-            </a:r>
-            <a:endParaRPr lang="en-US" sz="3000" dirty="0"/>
-          </a:p>
-        </p:txBody>
-      </p:sp>
-      <p:sp>
-        <p:nvSpPr>
-          <p:cNvPr id="7" name="Text 5"/>
-          <p:cNvSpPr/>
-          <p:nvPr/>
-        </p:nvSpPr>
-        <p:spPr>
-          <a:xfrm>
-            <a:off x="1737360" y="1938528"/>
-            <a:ext cx="4082796" cy="457200"/>
-          </a:xfrm>
-          <a:prstGeom prst="rect">
-            <a:avLst/>
-          </a:prstGeom>
-          <a:noFill/>
-          <a:ln/>
-        </p:spPr>
-        <p:txBody>
-          <a:bodyPr wrap="square" lIns="0" tIns="0" rIns="0" bIns="0" rtlCol="0" anchor="ctr"/>
-          <a:lstStyle/>
-          <a:p>
-            <a:pPr indent="0" marL="0">
-              <a:buNone/>
-            </a:pPr>
-            <a:r>
-              <a:rPr lang="en-US" sz="2300" dirty="0">
-                <a:solidFill>
-                  <a:srgbClr val="4A6B5D"/>
-                </a:solidFill>
-                <a:latin typeface="Georgia" pitchFamily="34" charset="0"/>
-                <a:ea typeface="Georgia" pitchFamily="34" charset="-122"/>
-                <a:cs typeface="Georgia" pitchFamily="34" charset="-120"/>
-              </a:rPr>
-              <a:t>Construction</a:t>
-            </a:r>
-            <a:endParaRPr lang="en-US" sz="2300" dirty="0"/>
-          </a:p>
-        </p:txBody>
-      </p:sp>
-      <p:sp>
-        <p:nvSpPr>
-          <p:cNvPr id="8" name="Text 6"/>
-          <p:cNvSpPr/>
-          <p:nvPr/>
-        </p:nvSpPr>
-        <p:spPr>
-          <a:xfrm>
-            <a:off x="1737360" y="2468880"/>
-            <a:ext cx="4082796" cy="1188720"/>
-          </a:xfrm>
-          <a:prstGeom prst="rect">
-            <a:avLst/>
-          </a:prstGeom>
-          <a:noFill/>
-          <a:ln/>
-        </p:spPr>
-        <p:txBody>
-          <a:bodyPr wrap="square" lIns="0" tIns="0" rIns="0" bIns="0" rtlCol="0" anchor="t"/>
-          <a:lstStyle/>
-          <a:p>
-            <a:pPr indent="0" marL="0">
-              <a:lnSpc>
-                <a:spcPts val="2100"/>
-              </a:lnSpc>
-              <a:buNone/>
-            </a:pPr>
-            <a:r>
-              <a:rPr lang="en-US" sz="1550" dirty="0">
-                <a:solidFill>
-                  <a:srgbClr val="24313F"/>
-                </a:solidFill>
-                <a:latin typeface="Georgia" pitchFamily="34" charset="0"/>
-                <a:ea typeface="Georgia" pitchFamily="34" charset="-122"/>
-                <a:cs typeface="Georgia" pitchFamily="34" charset="-120"/>
-              </a:rPr>
-              <a:t>What did we select and combine, and what did that leave out?</a:t>
-            </a:r>
-            <a:endParaRPr lang="en-US" sz="1550" dirty="0"/>
-          </a:p>
-        </p:txBody>
-      </p:sp>
-      <p:sp>
-        <p:nvSpPr>
-          <p:cNvPr id="9" name="Text 7"/>
-          <p:cNvSpPr/>
-          <p:nvPr/>
-        </p:nvSpPr>
-        <p:spPr>
-          <a:xfrm>
-            <a:off x="6368796" y="1920240"/>
-            <a:ext cx="914400" cy="548640"/>
-          </a:xfrm>
-          <a:prstGeom prst="rect">
-            <a:avLst/>
-          </a:prstGeom>
-          <a:noFill/>
-          <a:ln/>
-        </p:spPr>
-        <p:txBody>
-          <a:bodyPr wrap="square" lIns="0" tIns="0" rIns="0" bIns="0" rtlCol="0" anchor="ctr"/>
-          <a:lstStyle/>
-          <a:p>
-            <a:pPr indent="0" marL="0">
-              <a:buNone/>
-            </a:pPr>
-            <a:r>
-              <a:rPr lang="en-US" sz="3000" dirty="0">
-                <a:solidFill>
-                  <a:srgbClr val="A3C1AD"/>
-                </a:solidFill>
-                <a:latin typeface="Georgia" pitchFamily="34" charset="0"/>
-                <a:ea typeface="Georgia" pitchFamily="34" charset="-122"/>
-                <a:cs typeface="Georgia" pitchFamily="34" charset="-120"/>
-              </a:rPr>
-              <a:t>02</a:t>
-            </a:r>
-            <a:endParaRPr lang="en-US" sz="3000" dirty="0"/>
-          </a:p>
-        </p:txBody>
-      </p:sp>
-      <p:sp>
-        <p:nvSpPr>
-          <p:cNvPr id="10" name="Text 8"/>
-          <p:cNvSpPr/>
-          <p:nvPr/>
-        </p:nvSpPr>
-        <p:spPr>
-          <a:xfrm>
-            <a:off x="7283196" y="1938528"/>
-            <a:ext cx="4082796" cy="457200"/>
-          </a:xfrm>
-          <a:prstGeom prst="rect">
-            <a:avLst/>
-          </a:prstGeom>
-          <a:noFill/>
-          <a:ln/>
-        </p:spPr>
-        <p:txBody>
-          <a:bodyPr wrap="square" lIns="0" tIns="0" rIns="0" bIns="0" rtlCol="0" anchor="ctr"/>
-          <a:lstStyle/>
-          <a:p>
-            <a:pPr indent="0" marL="0">
-              <a:buNone/>
-            </a:pPr>
-            <a:r>
-              <a:rPr lang="en-US" sz="2300" dirty="0">
-                <a:solidFill>
-                  <a:srgbClr val="4A6B5D"/>
-                </a:solidFill>
-                <a:latin typeface="Georgia" pitchFamily="34" charset="0"/>
-                <a:ea typeface="Georgia" pitchFamily="34" charset="-122"/>
-                <a:cs typeface="Georgia" pitchFamily="34" charset="-120"/>
-              </a:rPr>
-              <a:t>Positions</a:t>
-            </a:r>
-            <a:endParaRPr lang="en-US" sz="2300" dirty="0"/>
-          </a:p>
-        </p:txBody>
-      </p:sp>
-      <p:sp>
-        <p:nvSpPr>
-          <p:cNvPr id="11" name="Text 9"/>
-          <p:cNvSpPr/>
-          <p:nvPr/>
-        </p:nvSpPr>
-        <p:spPr>
-          <a:xfrm>
-            <a:off x="7283196" y="2468880"/>
-            <a:ext cx="4082796" cy="1188720"/>
-          </a:xfrm>
-          <a:prstGeom prst="rect">
-            <a:avLst/>
-          </a:prstGeom>
-          <a:noFill/>
-          <a:ln/>
-        </p:spPr>
-        <p:txBody>
-          <a:bodyPr wrap="square" lIns="0" tIns="0" rIns="0" bIns="0" rtlCol="0" anchor="t"/>
-          <a:lstStyle/>
-          <a:p>
-            <a:pPr indent="0" marL="0">
-              <a:lnSpc>
-                <a:spcPts val="2100"/>
-              </a:lnSpc>
-              <a:buNone/>
-            </a:pPr>
-            <a:r>
-              <a:rPr lang="en-US" sz="1550" dirty="0">
-                <a:solidFill>
-                  <a:srgbClr val="24313F"/>
-                </a:solidFill>
-                <a:latin typeface="Georgia" pitchFamily="34" charset="0"/>
-                <a:ea typeface="Georgia" pitchFamily="34" charset="-122"/>
-                <a:cs typeface="Georgia" pitchFamily="34" charset="-120"/>
-              </a:rPr>
-              <a:t>What reading did we assume our audience would take?</a:t>
-            </a:r>
-            <a:endParaRPr lang="en-US" sz="1550" dirty="0"/>
-          </a:p>
-        </p:txBody>
-      </p:sp>
-      <p:sp>
-        <p:nvSpPr>
-          <p:cNvPr id="12" name="Text 10"/>
-          <p:cNvSpPr/>
-          <p:nvPr/>
-        </p:nvSpPr>
-        <p:spPr>
-          <a:xfrm>
-            <a:off x="822960" y="4114800"/>
-            <a:ext cx="914400" cy="548640"/>
-          </a:xfrm>
-          <a:prstGeom prst="rect">
-            <a:avLst/>
-          </a:prstGeom>
-          <a:noFill/>
-          <a:ln/>
-        </p:spPr>
-        <p:txBody>
-          <a:bodyPr wrap="square" lIns="0" tIns="0" rIns="0" bIns="0" rtlCol="0" anchor="ctr"/>
-          <a:lstStyle/>
-          <a:p>
-            <a:pPr indent="0" marL="0">
-              <a:buNone/>
-            </a:pPr>
-            <a:r>
-              <a:rPr lang="en-US" sz="3000" dirty="0">
-                <a:solidFill>
-                  <a:srgbClr val="A3C1AD"/>
-                </a:solidFill>
-                <a:latin typeface="Georgia" pitchFamily="34" charset="0"/>
-                <a:ea typeface="Georgia" pitchFamily="34" charset="-122"/>
-                <a:cs typeface="Georgia" pitchFamily="34" charset="-120"/>
-              </a:rPr>
-              <a:t>03</a:t>
-            </a:r>
-            <a:endParaRPr lang="en-US" sz="3000" dirty="0"/>
-          </a:p>
-        </p:txBody>
-      </p:sp>
-      <p:sp>
-        <p:nvSpPr>
-          <p:cNvPr id="13" name="Text 11"/>
-          <p:cNvSpPr/>
-          <p:nvPr/>
-        </p:nvSpPr>
-        <p:spPr>
-          <a:xfrm>
-            <a:off x="1737360" y="4133088"/>
-            <a:ext cx="4082796" cy="457200"/>
-          </a:xfrm>
-          <a:prstGeom prst="rect">
-            <a:avLst/>
-          </a:prstGeom>
-          <a:noFill/>
-          <a:ln/>
-        </p:spPr>
-        <p:txBody>
-          <a:bodyPr wrap="square" lIns="0" tIns="0" rIns="0" bIns="0" rtlCol="0" anchor="ctr"/>
-          <a:lstStyle/>
-          <a:p>
-            <a:pPr indent="0" marL="0">
-              <a:buNone/>
-            </a:pPr>
-            <a:r>
-              <a:rPr lang="en-US" sz="2300" dirty="0">
-                <a:solidFill>
-                  <a:srgbClr val="4A6B5D"/>
-                </a:solidFill>
-                <a:latin typeface="Georgia" pitchFamily="34" charset="0"/>
-                <a:ea typeface="Georgia" pitchFamily="34" charset="-122"/>
-                <a:cs typeface="Georgia" pitchFamily="34" charset="-120"/>
-              </a:rPr>
-              <a:t>Power</a:t>
-            </a:r>
-            <a:endParaRPr lang="en-US" sz="2300" dirty="0"/>
-          </a:p>
-        </p:txBody>
-      </p:sp>
-      <p:sp>
-        <p:nvSpPr>
-          <p:cNvPr id="14" name="Text 12"/>
-          <p:cNvSpPr/>
-          <p:nvPr/>
-        </p:nvSpPr>
-        <p:spPr>
-          <a:xfrm>
-            <a:off x="1737360" y="4663440"/>
-            <a:ext cx="4082796" cy="1188720"/>
-          </a:xfrm>
-          <a:prstGeom prst="rect">
-            <a:avLst/>
-          </a:prstGeom>
-          <a:noFill/>
-          <a:ln/>
-        </p:spPr>
-        <p:txBody>
-          <a:bodyPr wrap="square" lIns="0" tIns="0" rIns="0" bIns="0" rtlCol="0" anchor="t"/>
-          <a:lstStyle/>
-          <a:p>
-            <a:pPr indent="0" marL="0">
-              <a:lnSpc>
-                <a:spcPts val="2100"/>
-              </a:lnSpc>
-              <a:buNone/>
-            </a:pPr>
-            <a:r>
-              <a:rPr lang="en-US" sz="1550" dirty="0">
-                <a:solidFill>
-                  <a:srgbClr val="24313F"/>
-                </a:solidFill>
-                <a:latin typeface="Georgia" pitchFamily="34" charset="0"/>
-                <a:ea typeface="Georgia" pitchFamily="34" charset="-122"/>
-                <a:cs typeface="Georgia" pitchFamily="34" charset="-120"/>
-              </a:rPr>
-              <a:t>Whose shortcut did we borrow, and who pays for it?</a:t>
-            </a:r>
-            <a:endParaRPr lang="en-US" sz="1550" dirty="0"/>
-          </a:p>
-        </p:txBody>
-      </p:sp>
-      <p:sp>
-        <p:nvSpPr>
-          <p:cNvPr id="15" name="Text 13"/>
-          <p:cNvSpPr/>
-          <p:nvPr/>
-        </p:nvSpPr>
-        <p:spPr>
-          <a:xfrm>
-            <a:off x="6368796" y="4114800"/>
-            <a:ext cx="914400" cy="548640"/>
-          </a:xfrm>
-          <a:prstGeom prst="rect">
-            <a:avLst/>
-          </a:prstGeom>
-          <a:noFill/>
-          <a:ln/>
-        </p:spPr>
-        <p:txBody>
-          <a:bodyPr wrap="square" lIns="0" tIns="0" rIns="0" bIns="0" rtlCol="0" anchor="ctr"/>
-          <a:lstStyle/>
-          <a:p>
-            <a:pPr indent="0" marL="0">
-              <a:buNone/>
-            </a:pPr>
-            <a:r>
-              <a:rPr lang="en-US" sz="3000" dirty="0">
-                <a:solidFill>
-                  <a:srgbClr val="A3C1AD"/>
-                </a:solidFill>
-                <a:latin typeface="Georgia" pitchFamily="34" charset="0"/>
-                <a:ea typeface="Georgia" pitchFamily="34" charset="-122"/>
-                <a:cs typeface="Georgia" pitchFamily="34" charset="-120"/>
-              </a:rPr>
-              <a:t>04</a:t>
-            </a:r>
-            <a:endParaRPr lang="en-US" sz="3000" dirty="0"/>
-          </a:p>
-        </p:txBody>
-      </p:sp>
-      <p:sp>
-        <p:nvSpPr>
-          <p:cNvPr id="16" name="Text 14"/>
-          <p:cNvSpPr/>
-          <p:nvPr/>
-        </p:nvSpPr>
-        <p:spPr>
-          <a:xfrm>
-            <a:off x="7283196" y="4133088"/>
-            <a:ext cx="4082796" cy="457200"/>
-          </a:xfrm>
-          <a:prstGeom prst="rect">
-            <a:avLst/>
-          </a:prstGeom>
-          <a:noFill/>
-          <a:ln/>
-        </p:spPr>
-        <p:txBody>
-          <a:bodyPr wrap="square" lIns="0" tIns="0" rIns="0" bIns="0" rtlCol="0" anchor="ctr"/>
-          <a:lstStyle/>
-          <a:p>
-            <a:pPr indent="0" marL="0">
-              <a:buNone/>
-            </a:pPr>
-            <a:r>
-              <a:rPr lang="en-US" sz="2300" dirty="0">
-                <a:solidFill>
-                  <a:srgbClr val="4A6B5D"/>
-                </a:solidFill>
-                <a:latin typeface="Georgia" pitchFamily="34" charset="0"/>
-                <a:ea typeface="Georgia" pitchFamily="34" charset="-122"/>
-                <a:cs typeface="Georgia" pitchFamily="34" charset="-120"/>
-              </a:rPr>
-              <a:t>Absence</a:t>
-            </a:r>
-            <a:endParaRPr lang="en-US" sz="2300" dirty="0"/>
-          </a:p>
-        </p:txBody>
-      </p:sp>
-      <p:sp>
-        <p:nvSpPr>
-          <p:cNvPr id="17" name="Text 15"/>
-          <p:cNvSpPr/>
-          <p:nvPr/>
-        </p:nvSpPr>
-        <p:spPr>
-          <a:xfrm>
-            <a:off x="7283196" y="4663440"/>
-            <a:ext cx="4082796" cy="1188720"/>
-          </a:xfrm>
-          <a:prstGeom prst="rect">
-            <a:avLst/>
-          </a:prstGeom>
-          <a:noFill/>
-          <a:ln/>
-        </p:spPr>
-        <p:txBody>
-          <a:bodyPr wrap="square" lIns="0" tIns="0" rIns="0" bIns="0" rtlCol="0" anchor="t"/>
-          <a:lstStyle/>
-          <a:p>
-            <a:pPr indent="0" marL="0">
-              <a:lnSpc>
-                <a:spcPts val="2100"/>
-              </a:lnSpc>
-              <a:buNone/>
-            </a:pPr>
-            <a:r>
-              <a:rPr lang="en-US" sz="1550" dirty="0">
-                <a:solidFill>
-                  <a:srgbClr val="24313F"/>
-                </a:solidFill>
-                <a:latin typeface="Georgia" pitchFamily="34" charset="0"/>
-                <a:ea typeface="Georgia" pitchFamily="34" charset="-122"/>
-                <a:cs typeface="Georgia" pitchFamily="34" charset="-120"/>
-              </a:rPr>
-              <a:t>Who is missing from our product, by choice or by default?</a:t>
-            </a:r>
-            <a:endParaRPr lang="en-US" sz="1550" dirty="0"/>
-          </a:p>
-        </p:txBody>
-      </p:sp>
-      <p:sp>
-        <p:nvSpPr>
-          <p:cNvPr id="18" name="Text 16"/>
-          <p:cNvSpPr/>
-          <p:nvPr/>
-        </p:nvSpPr>
-        <p:spPr>
-          <a:xfrm>
-            <a:off x="822960" y="5989320"/>
-            <a:ext cx="10543032" cy="365760"/>
-          </a:xfrm>
-          <a:prstGeom prst="rect">
-            <a:avLst/>
-          </a:prstGeom>
-          <a:noFill/>
-          <a:ln/>
-        </p:spPr>
-        <p:txBody>
-          <a:bodyPr wrap="square" lIns="0" tIns="0" rIns="0" bIns="0" rtlCol="0" anchor="ctr"/>
-          <a:lstStyle/>
-          <a:p>
-            <a:pPr indent="0" marL="0">
-              <a:buNone/>
-            </a:pPr>
-            <a:r>
-              <a:rPr lang="en-US" sz="1150" i="1" dirty="0">
-                <a:solidFill>
-                  <a:srgbClr val="7A7F72"/>
-                </a:solidFill>
-                <a:latin typeface="Arial" pitchFamily="34" charset="0"/>
-                <a:ea typeface="Arial" pitchFamily="34" charset="-122"/>
-                <a:cs typeface="Arial" pitchFamily="34" charset="-120"/>
-              </a:rPr>
-              <a:t>A2 in Monday; the response cards become evidence Tuesday; LB3 posted on screening quality. The pickups are the homework.</a:t>
-            </a:r>
-            <a:endParaRPr lang="en-US" sz="1150" dirty="0"/>
-          </a:p>
-        </p:txBody>
-      </p:sp>
-      <p:sp>
-        <p:nvSpPr>
-          <p:cNvPr id="19" name="Shape 17"/>
-          <p:cNvSpPr/>
-          <p:nvPr/>
-        </p:nvSpPr>
-        <p:spPr>
-          <a:xfrm>
-            <a:off x="822960" y="6382512"/>
-            <a:ext cx="10543032" cy="0"/>
-          </a:xfrm>
-          <a:prstGeom prst="line">
-            <a:avLst/>
-          </a:prstGeom>
-          <a:noFill/>
+          <p:cNvPr id="5" name="Shape 3"/>
+          <p:cNvSpPr/>
+          <p:nvPr/>
+        </p:nvSpPr>
+        <p:spPr>
+          <a:xfrm>
+            <a:off x="822960" y="1097280"/>
+            <a:ext cx="5852160" cy="4206240"/>
+          </a:xfrm>
+          <a:prstGeom prst="rect">
+            <a:avLst/>
+          </a:prstGeom>
+          <a:solidFill>
+            <a:srgbClr val="FAF8F1"/>
+          </a:solidFill>
           <a:ln w="9525">
             <a:solidFill>
               <a:srgbClr val="D9D4C4"/>
@@ -3004,16 +2800,40 @@
           </a:ln>
         </p:spPr>
       </p:sp>
-      <p:sp>
-        <p:nvSpPr>
-          <p:cNvPr id="20" name="Text 18"/>
-          <p:cNvSpPr/>
-          <p:nvPr/>
-        </p:nvSpPr>
-        <p:spPr>
-          <a:xfrm>
-            <a:off x="822960" y="6419088"/>
-            <a:ext cx="7315200" cy="274320"/>
+      <p:pic>
+        <p:nvPicPr>
+          <p:cNvPr id="6" name="Image 0" descr="/Users/dogan/Documents/Vaults/Courses/wiki/classes/media-studies/decks/_build/img/lupin-vitrine.jpg">    </p:cNvPr>
+          <p:cNvPicPr>
+            <a:picLocks noChangeAspect="1"/>
+          </p:cNvPicPr>
+          <p:nvPr/>
+        </p:nvPicPr>
+        <p:blipFill>
+          <a:blip r:embed="rId1"/>
+          <a:stretch>
+            <a:fillRect/>
+          </a:stretch>
+        </p:blipFill>
+        <p:spPr>
+          <a:xfrm>
+            <a:off x="950976" y="1335024"/>
+            <a:ext cx="5596128" cy="3730752"/>
+          </a:xfrm>
+          <a:prstGeom prst="rect">
+            <a:avLst/>
+          </a:prstGeom>
+        </p:spPr>
+      </p:pic>
+      <p:sp>
+        <p:nvSpPr>
+          <p:cNvPr id="7" name="Text 4"/>
+          <p:cNvSpPr/>
+          <p:nvPr/>
+        </p:nvSpPr>
+        <p:spPr>
+          <a:xfrm>
+            <a:off x="822960" y="5349240"/>
+            <a:ext cx="5852160" cy="274320"/>
           </a:xfrm>
           <a:prstGeom prst="rect">
             <a:avLst/>
@@ -3025,11 +2845,11 @@
           <a:bodyPr wrap="square" lIns="0" tIns="0" rIns="0" bIns="0" rtlCol="0" anchor="ctr"/>
           <a:lstStyle/>
           <a:p>
-            <a:pPr indent="0" marL="0">
-              <a:buNone/>
-            </a:pPr>
-            <a:r>
-              <a:rPr lang="en-US" sz="900" spc="150" kern="0" dirty="0">
+            <a:pPr algn="ctr" indent="0" marL="0">
+              <a:buNone/>
+            </a:pPr>
+            <a:r>
+              <a:rPr lang="en-US" sz="1000" dirty="0">
                 <a:solidFill>
                   <a:srgbClr val="7A7F72"/>
                 </a:solidFill>
@@ -3037,46 +2857,264 @@
                 <a:ea typeface="Arial" pitchFamily="34" charset="-122"/>
                 <a:cs typeface="Arial" pitchFamily="34" charset="-120"/>
               </a:rPr>
-              <a:t>MEDIA STUDIES 9607 · SEMESTER I</a:t>
-            </a:r>
-            <a:endParaRPr lang="en-US" sz="900" dirty="0"/>
-          </a:p>
-        </p:txBody>
-      </p:sp>
-      <p:sp>
-        <p:nvSpPr>
-          <p:cNvPr id="21" name="Text 19"/>
-          <p:cNvSpPr/>
-          <p:nvPr/>
-        </p:nvSpPr>
-        <p:spPr>
-          <a:xfrm>
-            <a:off x="10268712" y="6355080"/>
-            <a:ext cx="1097280" cy="365760"/>
-          </a:xfrm>
-          <a:prstGeom prst="rect">
-            <a:avLst/>
-          </a:prstGeom>
-          <a:noFill/>
-          <a:ln/>
-        </p:spPr>
-        <p:txBody>
-          <a:bodyPr wrap="square" lIns="0" tIns="0" rIns="0" bIns="0" rtlCol="0" anchor="ctr"/>
-          <a:lstStyle/>
-          <a:p>
-            <a:pPr algn="r" indent="0" marL="0">
-              <a:buNone/>
-            </a:pPr>
-            <a:r>
-              <a:rPr lang="en-US" sz="1600" dirty="0">
-                <a:solidFill>
-                  <a:srgbClr val="A3C1AD"/>
+              <a:t>Lupin (Netflix, 2021): the cleaner the institution does not see</a:t>
+            </a:r>
+            <a:endParaRPr lang="en-US" sz="1000" dirty="0"/>
+          </a:p>
+        </p:txBody>
+      </p:sp>
+      <p:sp>
+        <p:nvSpPr>
+          <p:cNvPr id="8" name="Text 5"/>
+          <p:cNvSpPr/>
+          <p:nvPr/>
+        </p:nvSpPr>
+        <p:spPr>
+          <a:xfrm>
+            <a:off x="7086600" y="1280160"/>
+            <a:ext cx="4389120" cy="1371600"/>
+          </a:xfrm>
+          <a:prstGeom prst="rect">
+            <a:avLst/>
+          </a:prstGeom>
+          <a:noFill/>
+          <a:ln/>
+        </p:spPr>
+        <p:txBody>
+          <a:bodyPr wrap="square" lIns="0" tIns="0" rIns="0" bIns="0" rtlCol="0" anchor="t"/>
+          <a:lstStyle/>
+          <a:p>
+            <a:pPr indent="0" marL="0">
+              <a:lnSpc>
+                <a:spcPts val="3200"/>
+              </a:lnSpc>
+              <a:buNone/>
+            </a:pPr>
+            <a:r>
+              <a:rPr lang="en-US" sz="2600" dirty="0">
+                <a:solidFill>
+                  <a:srgbClr val="24313F"/>
                 </a:solidFill>
                 <a:latin typeface="Georgia" pitchFamily="34" charset="0"/>
                 <a:ea typeface="Georgia" pitchFamily="34" charset="-122"/>
                 <a:cs typeface="Georgia" pitchFamily="34" charset="-120"/>
               </a:rPr>
-              <a:t>04</a:t>
+              <a:t>What is never in the frame</a:t>
+            </a:r>
+            <a:endParaRPr lang="en-US" sz="2600" dirty="0"/>
+          </a:p>
+          <a:p>
+            <a:pPr indent="0" marL="0">
+              <a:lnSpc>
+                <a:spcPts val="3200"/>
+              </a:lnSpc>
+              <a:buNone/>
+            </a:pPr>
+            <a:r>
+              <a:rPr lang="en-US" sz="2600" dirty="0">
+                <a:solidFill>
+                  <a:srgbClr val="24313F"/>
+                </a:solidFill>
+                <a:latin typeface="Georgia" pitchFamily="34" charset="0"/>
+                <a:ea typeface="Georgia" pitchFamily="34" charset="-122"/>
+                <a:cs typeface="Georgia" pitchFamily="34" charset="-120"/>
+              </a:rPr>
+              <a:t>cannot be argued with</a:t>
+            </a:r>
+            <a:endParaRPr lang="en-US" sz="2600" dirty="0"/>
+          </a:p>
+        </p:txBody>
+      </p:sp>
+      <p:sp>
+        <p:nvSpPr>
+          <p:cNvPr id="9" name="Shape 6"/>
+          <p:cNvSpPr/>
+          <p:nvPr/>
+        </p:nvSpPr>
+        <p:spPr>
+          <a:xfrm>
+            <a:off x="7086600" y="2743200"/>
+            <a:ext cx="4297680" cy="0"/>
+          </a:xfrm>
+          <a:prstGeom prst="line">
+            <a:avLst/>
+          </a:prstGeom>
+          <a:noFill/>
+          <a:ln w="9525">
+            <a:solidFill>
+              <a:srgbClr val="D9D4C4"/>
+            </a:solidFill>
+            <a:prstDash val="solid"/>
+          </a:ln>
+        </p:spPr>
+      </p:sp>
+      <p:sp>
+        <p:nvSpPr>
+          <p:cNvPr id="10" name="Text 7"/>
+          <p:cNvSpPr/>
+          <p:nvPr/>
+        </p:nvSpPr>
+        <p:spPr>
+          <a:xfrm>
+            <a:off x="7086600" y="2926080"/>
+            <a:ext cx="4389120" cy="2926080"/>
+          </a:xfrm>
+          <a:prstGeom prst="rect">
+            <a:avLst/>
+          </a:prstGeom>
+          <a:noFill/>
+          <a:ln/>
+        </p:spPr>
+        <p:txBody>
+          <a:bodyPr wrap="square" lIns="0" tIns="0" rIns="0" bIns="0" rtlCol="0" anchor="t"/>
+          <a:lstStyle/>
+          <a:p>
+            <a:pPr indent="0" marL="0">
+              <a:lnSpc>
+                <a:spcPts val="2000"/>
+              </a:lnSpc>
+              <a:buNone/>
+            </a:pPr>
+            <a:r>
+              <a:rPr lang="en-US" sz="1450" dirty="0">
+                <a:solidFill>
+                  <a:srgbClr val="24313F"/>
+                </a:solidFill>
+                <a:latin typeface="Georgia" pitchFamily="34" charset="0"/>
+                <a:ea typeface="Georgia" pitchFamily="34" charset="-122"/>
+                <a:cs typeface="Georgia" pitchFamily="34" charset="-120"/>
+              </a:rPr>
+              <a:t>Who never appears cannot complain. Lupin builds its whole heist on the premise: the man in the worker's uniform is invisible to the museum because a class of person has been absented from attention.</a:t>
+            </a:r>
+            <a:endParaRPr lang="en-US" sz="1450" dirty="0"/>
+          </a:p>
+          <a:p>
+            <a:pPr indent="0" marL="0">
+              <a:lnSpc>
+                <a:spcPts val="2000"/>
+              </a:lnSpc>
+              <a:buNone/>
+            </a:pPr>
+            <a:endParaRPr lang="en-US" sz="1450" dirty="0"/>
+          </a:p>
+          <a:p>
+            <a:pPr indent="0" marL="0">
+              <a:lnSpc>
+                <a:spcPts val="2000"/>
+              </a:lnSpc>
+              <a:buNone/>
+            </a:pPr>
+            <a:r>
+              <a:rPr lang="en-US" sz="1450" dirty="0">
+                <a:solidFill>
+                  <a:srgbClr val="24313F"/>
+                </a:solidFill>
+                <a:latin typeface="Georgia" pitchFamily="34" charset="0"/>
+                <a:ea typeface="Georgia" pitchFamily="34" charset="-122"/>
+                <a:cs typeface="Georgia" pitchFamily="34" charset="-120"/>
+              </a:rPr>
+              <a:t>Run the inventory on your own product: who is missing, and did you choose that or default to it?</a:t>
+            </a:r>
+            <a:endParaRPr lang="en-US" sz="1450" dirty="0"/>
+          </a:p>
+        </p:txBody>
+      </p:sp>
+      <p:sp>
+        <p:nvSpPr>
+          <p:cNvPr id="11" name="Shape 8"/>
+          <p:cNvSpPr/>
+          <p:nvPr/>
+        </p:nvSpPr>
+        <p:spPr>
+          <a:xfrm>
+            <a:off x="822960" y="6382512"/>
+            <a:ext cx="10543032" cy="0"/>
+          </a:xfrm>
+          <a:prstGeom prst="line">
+            <a:avLst/>
+          </a:prstGeom>
+          <a:noFill/>
+          <a:ln w="9525">
+            <a:solidFill>
+              <a:srgbClr val="D9D4C4"/>
+            </a:solidFill>
+            <a:prstDash val="solid"/>
+          </a:ln>
+        </p:spPr>
+      </p:sp>
+      <p:sp>
+        <p:nvSpPr>
+          <p:cNvPr id="12" name="Text 9"/>
+          <p:cNvSpPr/>
+          <p:nvPr/>
+        </p:nvSpPr>
+        <p:spPr>
+          <a:xfrm>
+            <a:off x="822960" y="6419088"/>
+            <a:ext cx="7315200" cy="274320"/>
+          </a:xfrm>
+          <a:prstGeom prst="rect">
+            <a:avLst/>
+          </a:prstGeom>
+          <a:noFill/>
+          <a:ln/>
+        </p:spPr>
+        <p:txBody>
+          <a:bodyPr wrap="square" lIns="0" tIns="0" rIns="0" bIns="0" rtlCol="0" anchor="ctr"/>
+          <a:lstStyle/>
+          <a:p>
+            <a:pPr indent="0" marL="0">
+              <a:buNone/>
+            </a:pPr>
+            <a:r>
+              <a:rPr lang="en-US" sz="900" spc="150" kern="0" dirty="0">
+                <a:solidFill>
+                  <a:srgbClr val="7A7F72"/>
+                </a:solidFill>
+                <a:latin typeface="Arial" pitchFamily="34" charset="0"/>
+                <a:ea typeface="Arial" pitchFamily="34" charset="-122"/>
+                <a:cs typeface="Arial" pitchFamily="34" charset="-120"/>
+              </a:rPr>
+              <a:t>MEDIA STUDIES 9607 · SEMESTER I</a:t>
+            </a:r>
+            <a:endParaRPr lang="en-US" sz="900" dirty="0"/>
+          </a:p>
+        </p:txBody>
+      </p:sp>
+      <p:sp>
+        <p:nvSpPr>
+          <p:cNvPr id="13" name="Text 10"/>
+          <p:cNvSpPr/>
+          <p:nvPr/>
+        </p:nvSpPr>
+        <p:spPr>
+          <a:xfrm>
+            <a:off x="10268712" y="6355080"/>
+            <a:ext cx="1097280" cy="365760"/>
+          </a:xfrm>
+          <a:prstGeom prst="rect">
+            <a:avLst/>
+          </a:prstGeom>
+          <a:noFill/>
+          <a:ln/>
+        </p:spPr>
+        <p:txBody>
+          <a:bodyPr wrap="square" lIns="0" tIns="0" rIns="0" bIns="0" rtlCol="0" anchor="ctr"/>
+          <a:lstStyle/>
+          <a:p>
+            <a:pPr algn="r" indent="0" marL="0">
+              <a:buNone/>
+            </a:pPr>
+            <a:r>
+              <a:rPr lang="en-US" sz="1600" dirty="0">
+                <a:solidFill>
+                  <a:srgbClr val="A3C1AD"/>
+                </a:solidFill>
+                <a:latin typeface="Georgia" pitchFamily="34" charset="0"/>
+                <a:ea typeface="Georgia" pitchFamily="34" charset="-122"/>
+                <a:cs typeface="Georgia" pitchFamily="34" charset="-120"/>
+              </a:rPr>
+              <a:t>05</a:t>
             </a:r>
             <a:endParaRPr lang="en-US" sz="1600" dirty="0"/>
           </a:p>
@@ -3093,6 +3131,798 @@
 <file path=ppt/slides/slide12.xml><?xml version="1.0" encoding="utf-8"?>
 <p:sld xmlns:a="http://schemas.openxmlformats.org/drawingml/2006/main" xmlns:r="http://schemas.openxmlformats.org/officeDocument/2006/relationships" xmlns:p="http://schemas.openxmlformats.org/presentationml/2006/main">
   <p:cSld name="Slide 12">
+    <p:bg>
+      <p:bgPr>
+        <a:solidFill>
+          <a:srgbClr val="FAF8F1"/>
+        </a:solidFill>
+      </p:bgPr>
+    </p:bg>
+    <p:spTree>
+      <p:nvGrpSpPr>
+        <p:cNvPr id="1" name=""/>
+        <p:cNvGrpSpPr/>
+        <p:nvPr/>
+      </p:nvGrpSpPr>
+      <p:grpSpPr>
+        <a:xfrm>
+          <a:off x="0" y="0"/>
+          <a:ext cx="0" cy="0"/>
+          <a:chOff x="0" y="0"/>
+          <a:chExt cx="0" cy="0"/>
+        </a:xfrm>
+      </p:grpSpPr>
+      <p:sp>
+        <p:nvSpPr>
+          <p:cNvPr id="2" name="Text 0"/>
+          <p:cNvSpPr/>
+          <p:nvPr/>
+        </p:nvSpPr>
+        <p:spPr>
+          <a:xfrm>
+            <a:off x="822960" y="457200"/>
+            <a:ext cx="6400800" cy="274320"/>
+          </a:xfrm>
+          <a:prstGeom prst="rect">
+            <a:avLst/>
+          </a:prstGeom>
+          <a:noFill/>
+          <a:ln/>
+        </p:spPr>
+        <p:txBody>
+          <a:bodyPr wrap="square" lIns="0" tIns="0" rIns="0" bIns="0" rtlCol="0" anchor="ctr"/>
+          <a:lstStyle/>
+          <a:p>
+            <a:pPr algn="l" indent="0" marL="0">
+              <a:buNone/>
+            </a:pPr>
+            <a:r>
+              <a:rPr lang="en-US" sz="1100" b="1" spc="250" kern="0" dirty="0">
+                <a:solidFill>
+                  <a:srgbClr val="4A6B5D"/>
+                </a:solidFill>
+                <a:latin typeface="Arial" pitchFamily="34" charset="0"/>
+                <a:ea typeface="Arial" pitchFamily="34" charset="-122"/>
+                <a:cs typeface="Arial" pitchFamily="34" charset="-120"/>
+              </a:rPr>
+              <a:t>THE SELF-AUDIT</a:t>
+            </a:r>
+            <a:endParaRPr lang="en-US" sz="1100" dirty="0"/>
+          </a:p>
+        </p:txBody>
+      </p:sp>
+      <p:sp>
+        <p:nvSpPr>
+          <p:cNvPr id="3" name="Text 1"/>
+          <p:cNvSpPr/>
+          <p:nvPr/>
+        </p:nvSpPr>
+        <p:spPr>
+          <a:xfrm>
+            <a:off x="6793992" y="457200"/>
+            <a:ext cx="4572000" cy="274320"/>
+          </a:xfrm>
+          <a:prstGeom prst="rect">
+            <a:avLst/>
+          </a:prstGeom>
+          <a:noFill/>
+          <a:ln/>
+        </p:spPr>
+        <p:txBody>
+          <a:bodyPr wrap="square" lIns="0" tIns="0" rIns="0" bIns="0" rtlCol="0" anchor="ctr"/>
+          <a:lstStyle/>
+          <a:p>
+            <a:pPr algn="r" indent="0" marL="0">
+              <a:buNone/>
+            </a:pPr>
+            <a:r>
+              <a:rPr lang="en-US" sz="1100" b="1" spc="250" kern="0" dirty="0">
+                <a:solidFill>
+                  <a:srgbClr val="7A7F72"/>
+                </a:solidFill>
+                <a:latin typeface="Arial" pitchFamily="34" charset="0"/>
+                <a:ea typeface="Arial" pitchFamily="34" charset="-122"/>
+                <a:cs typeface="Arial" pitchFamily="34" charset="-120"/>
+              </a:rPr>
+              <a:t>THE WEEK'S FULL TOOLKIT, ON YOUR OWN CUT</a:t>
+            </a:r>
+            <a:endParaRPr lang="en-US" sz="1100" dirty="0"/>
+          </a:p>
+        </p:txBody>
+      </p:sp>
+      <p:sp>
+        <p:nvSpPr>
+          <p:cNvPr id="4" name="Shape 2"/>
+          <p:cNvSpPr/>
+          <p:nvPr/>
+        </p:nvSpPr>
+        <p:spPr>
+          <a:xfrm>
+            <a:off x="822960" y="786384"/>
+            <a:ext cx="10543032" cy="0"/>
+          </a:xfrm>
+          <a:prstGeom prst="line">
+            <a:avLst/>
+          </a:prstGeom>
+          <a:noFill/>
+          <a:ln w="9525">
+            <a:solidFill>
+              <a:srgbClr val="D9D4C4"/>
+            </a:solidFill>
+            <a:prstDash val="solid"/>
+          </a:ln>
+        </p:spPr>
+      </p:sp>
+      <p:sp>
+        <p:nvSpPr>
+          <p:cNvPr id="5" name="Text 3"/>
+          <p:cNvSpPr/>
+          <p:nvPr/>
+        </p:nvSpPr>
+        <p:spPr>
+          <a:xfrm>
+            <a:off x="822960" y="932688"/>
+            <a:ext cx="10543032" cy="640080"/>
+          </a:xfrm>
+          <a:prstGeom prst="rect">
+            <a:avLst/>
+          </a:prstGeom>
+          <a:noFill/>
+          <a:ln/>
+        </p:spPr>
+        <p:txBody>
+          <a:bodyPr wrap="square" lIns="0" tIns="0" rIns="0" bIns="0" rtlCol="0" anchor="ctr"/>
+          <a:lstStyle/>
+          <a:p>
+            <a:pPr indent="0" marL="0">
+              <a:buNone/>
+            </a:pPr>
+            <a:r>
+              <a:rPr lang="en-US" sz="3000" dirty="0">
+                <a:solidFill>
+                  <a:srgbClr val="24313F"/>
+                </a:solidFill>
+                <a:latin typeface="Georgia" pitchFamily="34" charset="0"/>
+                <a:ea typeface="Georgia" pitchFamily="34" charset="-122"/>
+                <a:cs typeface="Georgia" pitchFamily="34" charset="-120"/>
+              </a:rPr>
+              <a:t>Four questions of your own product</a:t>
+            </a:r>
+            <a:endParaRPr lang="en-US" sz="3000" dirty="0"/>
+          </a:p>
+        </p:txBody>
+      </p:sp>
+      <p:sp>
+        <p:nvSpPr>
+          <p:cNvPr id="6" name="Text 4"/>
+          <p:cNvSpPr/>
+          <p:nvPr/>
+        </p:nvSpPr>
+        <p:spPr>
+          <a:xfrm>
+            <a:off x="822960" y="1920240"/>
+            <a:ext cx="914400" cy="548640"/>
+          </a:xfrm>
+          <a:prstGeom prst="rect">
+            <a:avLst/>
+          </a:prstGeom>
+          <a:noFill/>
+          <a:ln/>
+        </p:spPr>
+        <p:txBody>
+          <a:bodyPr wrap="square" lIns="0" tIns="0" rIns="0" bIns="0" rtlCol="0" anchor="ctr"/>
+          <a:lstStyle/>
+          <a:p>
+            <a:pPr indent="0" marL="0">
+              <a:buNone/>
+            </a:pPr>
+            <a:r>
+              <a:rPr lang="en-US" sz="3000" dirty="0">
+                <a:solidFill>
+                  <a:srgbClr val="A3C1AD"/>
+                </a:solidFill>
+                <a:latin typeface="Georgia" pitchFamily="34" charset="0"/>
+                <a:ea typeface="Georgia" pitchFamily="34" charset="-122"/>
+                <a:cs typeface="Georgia" pitchFamily="34" charset="-120"/>
+              </a:rPr>
+              <a:t>01</a:t>
+            </a:r>
+            <a:endParaRPr lang="en-US" sz="3000" dirty="0"/>
+          </a:p>
+        </p:txBody>
+      </p:sp>
+      <p:sp>
+        <p:nvSpPr>
+          <p:cNvPr id="7" name="Text 5"/>
+          <p:cNvSpPr/>
+          <p:nvPr/>
+        </p:nvSpPr>
+        <p:spPr>
+          <a:xfrm>
+            <a:off x="1737360" y="1938528"/>
+            <a:ext cx="4082796" cy="457200"/>
+          </a:xfrm>
+          <a:prstGeom prst="rect">
+            <a:avLst/>
+          </a:prstGeom>
+          <a:noFill/>
+          <a:ln/>
+        </p:spPr>
+        <p:txBody>
+          <a:bodyPr wrap="square" lIns="0" tIns="0" rIns="0" bIns="0" rtlCol="0" anchor="ctr"/>
+          <a:lstStyle/>
+          <a:p>
+            <a:pPr indent="0" marL="0">
+              <a:buNone/>
+            </a:pPr>
+            <a:r>
+              <a:rPr lang="en-US" sz="2300" dirty="0">
+                <a:solidFill>
+                  <a:srgbClr val="4A6B5D"/>
+                </a:solidFill>
+                <a:latin typeface="Georgia" pitchFamily="34" charset="0"/>
+                <a:ea typeface="Georgia" pitchFamily="34" charset="-122"/>
+                <a:cs typeface="Georgia" pitchFamily="34" charset="-120"/>
+              </a:rPr>
+              <a:t>Construction</a:t>
+            </a:r>
+            <a:endParaRPr lang="en-US" sz="2300" dirty="0"/>
+          </a:p>
+        </p:txBody>
+      </p:sp>
+      <p:sp>
+        <p:nvSpPr>
+          <p:cNvPr id="8" name="Text 6"/>
+          <p:cNvSpPr/>
+          <p:nvPr/>
+        </p:nvSpPr>
+        <p:spPr>
+          <a:xfrm>
+            <a:off x="1737360" y="2468880"/>
+            <a:ext cx="4082796" cy="1188720"/>
+          </a:xfrm>
+          <a:prstGeom prst="rect">
+            <a:avLst/>
+          </a:prstGeom>
+          <a:noFill/>
+          <a:ln/>
+        </p:spPr>
+        <p:txBody>
+          <a:bodyPr wrap="square" lIns="0" tIns="0" rIns="0" bIns="0" rtlCol="0" anchor="t"/>
+          <a:lstStyle/>
+          <a:p>
+            <a:pPr indent="0" marL="0">
+              <a:lnSpc>
+                <a:spcPts val="2100"/>
+              </a:lnSpc>
+              <a:buNone/>
+            </a:pPr>
+            <a:r>
+              <a:rPr lang="en-US" sz="1550" dirty="0">
+                <a:solidFill>
+                  <a:srgbClr val="24313F"/>
+                </a:solidFill>
+                <a:latin typeface="Georgia" pitchFamily="34" charset="0"/>
+                <a:ea typeface="Georgia" pitchFamily="34" charset="-122"/>
+                <a:cs typeface="Georgia" pitchFamily="34" charset="-120"/>
+              </a:rPr>
+              <a:t>What did we select and combine, and what did that leave out?</a:t>
+            </a:r>
+            <a:endParaRPr lang="en-US" sz="1550" dirty="0"/>
+          </a:p>
+        </p:txBody>
+      </p:sp>
+      <p:sp>
+        <p:nvSpPr>
+          <p:cNvPr id="9" name="Text 7"/>
+          <p:cNvSpPr/>
+          <p:nvPr/>
+        </p:nvSpPr>
+        <p:spPr>
+          <a:xfrm>
+            <a:off x="6368796" y="1920240"/>
+            <a:ext cx="914400" cy="548640"/>
+          </a:xfrm>
+          <a:prstGeom prst="rect">
+            <a:avLst/>
+          </a:prstGeom>
+          <a:noFill/>
+          <a:ln/>
+        </p:spPr>
+        <p:txBody>
+          <a:bodyPr wrap="square" lIns="0" tIns="0" rIns="0" bIns="0" rtlCol="0" anchor="ctr"/>
+          <a:lstStyle/>
+          <a:p>
+            <a:pPr indent="0" marL="0">
+              <a:buNone/>
+            </a:pPr>
+            <a:r>
+              <a:rPr lang="en-US" sz="3000" dirty="0">
+                <a:solidFill>
+                  <a:srgbClr val="A3C1AD"/>
+                </a:solidFill>
+                <a:latin typeface="Georgia" pitchFamily="34" charset="0"/>
+                <a:ea typeface="Georgia" pitchFamily="34" charset="-122"/>
+                <a:cs typeface="Georgia" pitchFamily="34" charset="-120"/>
+              </a:rPr>
+              <a:t>02</a:t>
+            </a:r>
+            <a:endParaRPr lang="en-US" sz="3000" dirty="0"/>
+          </a:p>
+        </p:txBody>
+      </p:sp>
+      <p:sp>
+        <p:nvSpPr>
+          <p:cNvPr id="10" name="Text 8"/>
+          <p:cNvSpPr/>
+          <p:nvPr/>
+        </p:nvSpPr>
+        <p:spPr>
+          <a:xfrm>
+            <a:off x="7283196" y="1938528"/>
+            <a:ext cx="4082796" cy="457200"/>
+          </a:xfrm>
+          <a:prstGeom prst="rect">
+            <a:avLst/>
+          </a:prstGeom>
+          <a:noFill/>
+          <a:ln/>
+        </p:spPr>
+        <p:txBody>
+          <a:bodyPr wrap="square" lIns="0" tIns="0" rIns="0" bIns="0" rtlCol="0" anchor="ctr"/>
+          <a:lstStyle/>
+          <a:p>
+            <a:pPr indent="0" marL="0">
+              <a:buNone/>
+            </a:pPr>
+            <a:r>
+              <a:rPr lang="en-US" sz="2300" dirty="0">
+                <a:solidFill>
+                  <a:srgbClr val="4A6B5D"/>
+                </a:solidFill>
+                <a:latin typeface="Georgia" pitchFamily="34" charset="0"/>
+                <a:ea typeface="Georgia" pitchFamily="34" charset="-122"/>
+                <a:cs typeface="Georgia" pitchFamily="34" charset="-120"/>
+              </a:rPr>
+              <a:t>Positions</a:t>
+            </a:r>
+            <a:endParaRPr lang="en-US" sz="2300" dirty="0"/>
+          </a:p>
+        </p:txBody>
+      </p:sp>
+      <p:sp>
+        <p:nvSpPr>
+          <p:cNvPr id="11" name="Text 9"/>
+          <p:cNvSpPr/>
+          <p:nvPr/>
+        </p:nvSpPr>
+        <p:spPr>
+          <a:xfrm>
+            <a:off x="7283196" y="2468880"/>
+            <a:ext cx="4082796" cy="1188720"/>
+          </a:xfrm>
+          <a:prstGeom prst="rect">
+            <a:avLst/>
+          </a:prstGeom>
+          <a:noFill/>
+          <a:ln/>
+        </p:spPr>
+        <p:txBody>
+          <a:bodyPr wrap="square" lIns="0" tIns="0" rIns="0" bIns="0" rtlCol="0" anchor="t"/>
+          <a:lstStyle/>
+          <a:p>
+            <a:pPr indent="0" marL="0">
+              <a:lnSpc>
+                <a:spcPts val="2100"/>
+              </a:lnSpc>
+              <a:buNone/>
+            </a:pPr>
+            <a:r>
+              <a:rPr lang="en-US" sz="1550" dirty="0">
+                <a:solidFill>
+                  <a:srgbClr val="24313F"/>
+                </a:solidFill>
+                <a:latin typeface="Georgia" pitchFamily="34" charset="0"/>
+                <a:ea typeface="Georgia" pitchFamily="34" charset="-122"/>
+                <a:cs typeface="Georgia" pitchFamily="34" charset="-120"/>
+              </a:rPr>
+              <a:t>What reading did we assume our audience would take?</a:t>
+            </a:r>
+            <a:endParaRPr lang="en-US" sz="1550" dirty="0"/>
+          </a:p>
+        </p:txBody>
+      </p:sp>
+      <p:sp>
+        <p:nvSpPr>
+          <p:cNvPr id="12" name="Text 10"/>
+          <p:cNvSpPr/>
+          <p:nvPr/>
+        </p:nvSpPr>
+        <p:spPr>
+          <a:xfrm>
+            <a:off x="822960" y="4114800"/>
+            <a:ext cx="914400" cy="548640"/>
+          </a:xfrm>
+          <a:prstGeom prst="rect">
+            <a:avLst/>
+          </a:prstGeom>
+          <a:noFill/>
+          <a:ln/>
+        </p:spPr>
+        <p:txBody>
+          <a:bodyPr wrap="square" lIns="0" tIns="0" rIns="0" bIns="0" rtlCol="0" anchor="ctr"/>
+          <a:lstStyle/>
+          <a:p>
+            <a:pPr indent="0" marL="0">
+              <a:buNone/>
+            </a:pPr>
+            <a:r>
+              <a:rPr lang="en-US" sz="3000" dirty="0">
+                <a:solidFill>
+                  <a:srgbClr val="A3C1AD"/>
+                </a:solidFill>
+                <a:latin typeface="Georgia" pitchFamily="34" charset="0"/>
+                <a:ea typeface="Georgia" pitchFamily="34" charset="-122"/>
+                <a:cs typeface="Georgia" pitchFamily="34" charset="-120"/>
+              </a:rPr>
+              <a:t>03</a:t>
+            </a:r>
+            <a:endParaRPr lang="en-US" sz="3000" dirty="0"/>
+          </a:p>
+        </p:txBody>
+      </p:sp>
+      <p:sp>
+        <p:nvSpPr>
+          <p:cNvPr id="13" name="Text 11"/>
+          <p:cNvSpPr/>
+          <p:nvPr/>
+        </p:nvSpPr>
+        <p:spPr>
+          <a:xfrm>
+            <a:off x="1737360" y="4133088"/>
+            <a:ext cx="4082796" cy="457200"/>
+          </a:xfrm>
+          <a:prstGeom prst="rect">
+            <a:avLst/>
+          </a:prstGeom>
+          <a:noFill/>
+          <a:ln/>
+        </p:spPr>
+        <p:txBody>
+          <a:bodyPr wrap="square" lIns="0" tIns="0" rIns="0" bIns="0" rtlCol="0" anchor="ctr"/>
+          <a:lstStyle/>
+          <a:p>
+            <a:pPr indent="0" marL="0">
+              <a:buNone/>
+            </a:pPr>
+            <a:r>
+              <a:rPr lang="en-US" sz="2300" dirty="0">
+                <a:solidFill>
+                  <a:srgbClr val="4A6B5D"/>
+                </a:solidFill>
+                <a:latin typeface="Georgia" pitchFamily="34" charset="0"/>
+                <a:ea typeface="Georgia" pitchFamily="34" charset="-122"/>
+                <a:cs typeface="Georgia" pitchFamily="34" charset="-120"/>
+              </a:rPr>
+              <a:t>Power</a:t>
+            </a:r>
+            <a:endParaRPr lang="en-US" sz="2300" dirty="0"/>
+          </a:p>
+        </p:txBody>
+      </p:sp>
+      <p:sp>
+        <p:nvSpPr>
+          <p:cNvPr id="14" name="Text 12"/>
+          <p:cNvSpPr/>
+          <p:nvPr/>
+        </p:nvSpPr>
+        <p:spPr>
+          <a:xfrm>
+            <a:off x="1737360" y="4663440"/>
+            <a:ext cx="4082796" cy="1188720"/>
+          </a:xfrm>
+          <a:prstGeom prst="rect">
+            <a:avLst/>
+          </a:prstGeom>
+          <a:noFill/>
+          <a:ln/>
+        </p:spPr>
+        <p:txBody>
+          <a:bodyPr wrap="square" lIns="0" tIns="0" rIns="0" bIns="0" rtlCol="0" anchor="t"/>
+          <a:lstStyle/>
+          <a:p>
+            <a:pPr indent="0" marL="0">
+              <a:lnSpc>
+                <a:spcPts val="2100"/>
+              </a:lnSpc>
+              <a:buNone/>
+            </a:pPr>
+            <a:r>
+              <a:rPr lang="en-US" sz="1550" dirty="0">
+                <a:solidFill>
+                  <a:srgbClr val="24313F"/>
+                </a:solidFill>
+                <a:latin typeface="Georgia" pitchFamily="34" charset="0"/>
+                <a:ea typeface="Georgia" pitchFamily="34" charset="-122"/>
+                <a:cs typeface="Georgia" pitchFamily="34" charset="-120"/>
+              </a:rPr>
+              <a:t>Whose shortcut did we borrow, and who pays for it?</a:t>
+            </a:r>
+            <a:endParaRPr lang="en-US" sz="1550" dirty="0"/>
+          </a:p>
+        </p:txBody>
+      </p:sp>
+      <p:sp>
+        <p:nvSpPr>
+          <p:cNvPr id="15" name="Text 13"/>
+          <p:cNvSpPr/>
+          <p:nvPr/>
+        </p:nvSpPr>
+        <p:spPr>
+          <a:xfrm>
+            <a:off x="6368796" y="4114800"/>
+            <a:ext cx="914400" cy="548640"/>
+          </a:xfrm>
+          <a:prstGeom prst="rect">
+            <a:avLst/>
+          </a:prstGeom>
+          <a:noFill/>
+          <a:ln/>
+        </p:spPr>
+        <p:txBody>
+          <a:bodyPr wrap="square" lIns="0" tIns="0" rIns="0" bIns="0" rtlCol="0" anchor="ctr"/>
+          <a:lstStyle/>
+          <a:p>
+            <a:pPr indent="0" marL="0">
+              <a:buNone/>
+            </a:pPr>
+            <a:r>
+              <a:rPr lang="en-US" sz="3000" dirty="0">
+                <a:solidFill>
+                  <a:srgbClr val="A3C1AD"/>
+                </a:solidFill>
+                <a:latin typeface="Georgia" pitchFamily="34" charset="0"/>
+                <a:ea typeface="Georgia" pitchFamily="34" charset="-122"/>
+                <a:cs typeface="Georgia" pitchFamily="34" charset="-120"/>
+              </a:rPr>
+              <a:t>04</a:t>
+            </a:r>
+            <a:endParaRPr lang="en-US" sz="3000" dirty="0"/>
+          </a:p>
+        </p:txBody>
+      </p:sp>
+      <p:sp>
+        <p:nvSpPr>
+          <p:cNvPr id="16" name="Text 14"/>
+          <p:cNvSpPr/>
+          <p:nvPr/>
+        </p:nvSpPr>
+        <p:spPr>
+          <a:xfrm>
+            <a:off x="7283196" y="4133088"/>
+            <a:ext cx="4082796" cy="457200"/>
+          </a:xfrm>
+          <a:prstGeom prst="rect">
+            <a:avLst/>
+          </a:prstGeom>
+          <a:noFill/>
+          <a:ln/>
+        </p:spPr>
+        <p:txBody>
+          <a:bodyPr wrap="square" lIns="0" tIns="0" rIns="0" bIns="0" rtlCol="0" anchor="ctr"/>
+          <a:lstStyle/>
+          <a:p>
+            <a:pPr indent="0" marL="0">
+              <a:buNone/>
+            </a:pPr>
+            <a:r>
+              <a:rPr lang="en-US" sz="2300" dirty="0">
+                <a:solidFill>
+                  <a:srgbClr val="4A6B5D"/>
+                </a:solidFill>
+                <a:latin typeface="Georgia" pitchFamily="34" charset="0"/>
+                <a:ea typeface="Georgia" pitchFamily="34" charset="-122"/>
+                <a:cs typeface="Georgia" pitchFamily="34" charset="-120"/>
+              </a:rPr>
+              <a:t>Absence</a:t>
+            </a:r>
+            <a:endParaRPr lang="en-US" sz="2300" dirty="0"/>
+          </a:p>
+        </p:txBody>
+      </p:sp>
+      <p:sp>
+        <p:nvSpPr>
+          <p:cNvPr id="17" name="Text 15"/>
+          <p:cNvSpPr/>
+          <p:nvPr/>
+        </p:nvSpPr>
+        <p:spPr>
+          <a:xfrm>
+            <a:off x="7283196" y="4663440"/>
+            <a:ext cx="4082796" cy="1188720"/>
+          </a:xfrm>
+          <a:prstGeom prst="rect">
+            <a:avLst/>
+          </a:prstGeom>
+          <a:noFill/>
+          <a:ln/>
+        </p:spPr>
+        <p:txBody>
+          <a:bodyPr wrap="square" lIns="0" tIns="0" rIns="0" bIns="0" rtlCol="0" anchor="t"/>
+          <a:lstStyle/>
+          <a:p>
+            <a:pPr indent="0" marL="0">
+              <a:lnSpc>
+                <a:spcPts val="2100"/>
+              </a:lnSpc>
+              <a:buNone/>
+            </a:pPr>
+            <a:r>
+              <a:rPr lang="en-US" sz="1550" dirty="0">
+                <a:solidFill>
+                  <a:srgbClr val="24313F"/>
+                </a:solidFill>
+                <a:latin typeface="Georgia" pitchFamily="34" charset="0"/>
+                <a:ea typeface="Georgia" pitchFamily="34" charset="-122"/>
+                <a:cs typeface="Georgia" pitchFamily="34" charset="-120"/>
+              </a:rPr>
+              <a:t>Who is missing from our product, by choice or by default?</a:t>
+            </a:r>
+            <a:endParaRPr lang="en-US" sz="1550" dirty="0"/>
+          </a:p>
+        </p:txBody>
+      </p:sp>
+      <p:sp>
+        <p:nvSpPr>
+          <p:cNvPr id="18" name="Text 16"/>
+          <p:cNvSpPr/>
+          <p:nvPr/>
+        </p:nvSpPr>
+        <p:spPr>
+          <a:xfrm>
+            <a:off x="822960" y="5989320"/>
+            <a:ext cx="10543032" cy="365760"/>
+          </a:xfrm>
+          <a:prstGeom prst="rect">
+            <a:avLst/>
+          </a:prstGeom>
+          <a:noFill/>
+          <a:ln/>
+        </p:spPr>
+        <p:txBody>
+          <a:bodyPr wrap="square" lIns="0" tIns="0" rIns="0" bIns="0" rtlCol="0" anchor="ctr"/>
+          <a:lstStyle/>
+          <a:p>
+            <a:pPr indent="0" marL="0">
+              <a:buNone/>
+            </a:pPr>
+            <a:r>
+              <a:rPr lang="en-US" sz="1150" i="1" dirty="0">
+                <a:solidFill>
+                  <a:srgbClr val="7A7F72"/>
+                </a:solidFill>
+                <a:latin typeface="Arial" pitchFamily="34" charset="0"/>
+                <a:ea typeface="Arial" pitchFamily="34" charset="-122"/>
+                <a:cs typeface="Arial" pitchFamily="34" charset="-120"/>
+              </a:rPr>
+              <a:t>A2 in Monday; the response cards become evidence Tuesday; LB3 posted on screening quality. The pickups are the homework.</a:t>
+            </a:r>
+            <a:endParaRPr lang="en-US" sz="1150" dirty="0"/>
+          </a:p>
+        </p:txBody>
+      </p:sp>
+      <p:sp>
+        <p:nvSpPr>
+          <p:cNvPr id="19" name="Shape 17"/>
+          <p:cNvSpPr/>
+          <p:nvPr/>
+        </p:nvSpPr>
+        <p:spPr>
+          <a:xfrm>
+            <a:off x="822960" y="6382512"/>
+            <a:ext cx="10543032" cy="0"/>
+          </a:xfrm>
+          <a:prstGeom prst="line">
+            <a:avLst/>
+          </a:prstGeom>
+          <a:noFill/>
+          <a:ln w="9525">
+            <a:solidFill>
+              <a:srgbClr val="D9D4C4"/>
+            </a:solidFill>
+            <a:prstDash val="solid"/>
+          </a:ln>
+        </p:spPr>
+      </p:sp>
+      <p:sp>
+        <p:nvSpPr>
+          <p:cNvPr id="20" name="Text 18"/>
+          <p:cNvSpPr/>
+          <p:nvPr/>
+        </p:nvSpPr>
+        <p:spPr>
+          <a:xfrm>
+            <a:off x="822960" y="6419088"/>
+            <a:ext cx="7315200" cy="274320"/>
+          </a:xfrm>
+          <a:prstGeom prst="rect">
+            <a:avLst/>
+          </a:prstGeom>
+          <a:noFill/>
+          <a:ln/>
+        </p:spPr>
+        <p:txBody>
+          <a:bodyPr wrap="square" lIns="0" tIns="0" rIns="0" bIns="0" rtlCol="0" anchor="ctr"/>
+          <a:lstStyle/>
+          <a:p>
+            <a:pPr indent="0" marL="0">
+              <a:buNone/>
+            </a:pPr>
+            <a:r>
+              <a:rPr lang="en-US" sz="900" spc="150" kern="0" dirty="0">
+                <a:solidFill>
+                  <a:srgbClr val="7A7F72"/>
+                </a:solidFill>
+                <a:latin typeface="Arial" pitchFamily="34" charset="0"/>
+                <a:ea typeface="Arial" pitchFamily="34" charset="-122"/>
+                <a:cs typeface="Arial" pitchFamily="34" charset="-120"/>
+              </a:rPr>
+              <a:t>MEDIA STUDIES 9607 · SEMESTER I</a:t>
+            </a:r>
+            <a:endParaRPr lang="en-US" sz="900" dirty="0"/>
+          </a:p>
+        </p:txBody>
+      </p:sp>
+      <p:sp>
+        <p:nvSpPr>
+          <p:cNvPr id="21" name="Text 19"/>
+          <p:cNvSpPr/>
+          <p:nvPr/>
+        </p:nvSpPr>
+        <p:spPr>
+          <a:xfrm>
+            <a:off x="10268712" y="6355080"/>
+            <a:ext cx="1097280" cy="365760"/>
+          </a:xfrm>
+          <a:prstGeom prst="rect">
+            <a:avLst/>
+          </a:prstGeom>
+          <a:noFill/>
+          <a:ln/>
+        </p:spPr>
+        <p:txBody>
+          <a:bodyPr wrap="square" lIns="0" tIns="0" rIns="0" bIns="0" rtlCol="0" anchor="ctr"/>
+          <a:lstStyle/>
+          <a:p>
+            <a:pPr algn="r" indent="0" marL="0">
+              <a:buNone/>
+            </a:pPr>
+            <a:r>
+              <a:rPr lang="en-US" sz="1600" dirty="0">
+                <a:solidFill>
+                  <a:srgbClr val="A3C1AD"/>
+                </a:solidFill>
+                <a:latin typeface="Georgia" pitchFamily="34" charset="0"/>
+                <a:ea typeface="Georgia" pitchFamily="34" charset="-122"/>
+                <a:cs typeface="Georgia" pitchFamily="34" charset="-120"/>
+              </a:rPr>
+              <a:t>06</a:t>
+            </a:r>
+            <a:endParaRPr lang="en-US" sz="1600" dirty="0"/>
+          </a:p>
+        </p:txBody>
+      </p:sp>
+    </p:spTree>
+  </p:cSld>
+  <p:clrMapOvr>
+    <a:masterClrMapping/>
+  </p:clrMapOvr>
+</p:sld>
+</file>
+
+<file path=ppt/slides/slide13.xml><?xml version="1.0" encoding="utf-8"?>
+<p:sld xmlns:a="http://schemas.openxmlformats.org/drawingml/2006/main" xmlns:r="http://schemas.openxmlformats.org/officeDocument/2006/relationships" xmlns:p="http://schemas.openxmlformats.org/presentationml/2006/main">
+  <p:cSld name="Slide 13">
     <p:bg>
       <p:bgPr>
         <a:solidFill>
@@ -3349,7 +4179,7 @@
                 <a:ea typeface="Georgia" pitchFamily="34" charset="-122"/>
                 <a:cs typeface="Georgia" pitchFamily="34" charset="-120"/>
               </a:rPr>
-              <a:t>05</a:t>
+              <a:t>07</a:t>
             </a:r>
             <a:endParaRPr lang="en-US" sz="1600" dirty="0"/>
           </a:p>
@@ -5653,7 +6483,7 @@
                 <a:ea typeface="Arial" pitchFamily="34" charset="-122"/>
                 <a:cs typeface="Arial" pitchFamily="34" charset="-120"/>
               </a:rPr>
-              <a:t>STEREOTYPING AS POWER</a:t>
+              <a:t>NATION BRANDING</a:t>
             </a:r>
             <a:endParaRPr lang="en-US" sz="1100" dirty="0"/>
           </a:p>
@@ -5692,7 +6522,7 @@
                 <a:ea typeface="Arial" pitchFamily="34" charset="-122"/>
                 <a:cs typeface="Arial" pitchFamily="34" charset="-120"/>
               </a:rPr>
-              <a:t>WHO BENEFITS, WHO PAYS</a:t>
+              <a:t>DOWNTON'S BRITAIN, WORKED IN FULL</a:t>
             </a:r>
             <a:endParaRPr lang="en-US" sz="1100" dirty="0"/>
           </a:p>
@@ -5723,14 +6553,63 @@
       </p:sp>
       <p:sp>
         <p:nvSpPr>
-          <p:cNvPr id="5" name="Text 3"/>
-          <p:cNvSpPr/>
-          <p:nvPr/>
-        </p:nvSpPr>
-        <p:spPr>
-          <a:xfrm>
-            <a:off x="822960" y="1280160"/>
-            <a:ext cx="10543032" cy="914400"/>
+          <p:cNvPr id="5" name="Shape 3"/>
+          <p:cNvSpPr/>
+          <p:nvPr/>
+        </p:nvSpPr>
+        <p:spPr>
+          <a:xfrm>
+            <a:off x="822960" y="1143000"/>
+            <a:ext cx="2361438" cy="2377440"/>
+          </a:xfrm>
+          <a:prstGeom prst="rect">
+            <a:avLst/>
+          </a:prstGeom>
+          <a:solidFill>
+            <a:srgbClr val="FAF8F1"/>
+          </a:solidFill>
+          <a:ln w="9525">
+            <a:solidFill>
+              <a:srgbClr val="D9D4C4"/>
+            </a:solidFill>
+            <a:prstDash val="solid"/>
+          </a:ln>
+        </p:spPr>
+      </p:sp>
+      <p:pic>
+        <p:nvPicPr>
+          <p:cNvPr id="6" name="Image 0" descr="/Users/dogan/Documents/Vaults/Courses/wiki/classes/media-studies/decks/_build/img/downton-house.jpg">    </p:cNvPr>
+          <p:cNvPicPr>
+            <a:picLocks noChangeAspect="1"/>
+          </p:cNvPicPr>
+          <p:nvPr/>
+        </p:nvPicPr>
+        <p:blipFill>
+          <a:blip r:embed="rId1"/>
+          <a:stretch>
+            <a:fillRect/>
+          </a:stretch>
+        </p:blipFill>
+        <p:spPr>
+          <a:xfrm>
+            <a:off x="992695" y="1216152"/>
+            <a:ext cx="2021967" cy="2231136"/>
+          </a:xfrm>
+          <a:prstGeom prst="rect">
+            <a:avLst/>
+          </a:prstGeom>
+        </p:spPr>
+      </p:pic>
+      <p:sp>
+        <p:nvSpPr>
+          <p:cNvPr id="7" name="Text 4"/>
+          <p:cNvSpPr/>
+          <p:nvPr/>
+        </p:nvSpPr>
+        <p:spPr>
+          <a:xfrm>
+            <a:off x="822960" y="3566160"/>
+            <a:ext cx="2361438" cy="320040"/>
           </a:xfrm>
           <a:prstGeom prst="rect">
             <a:avLst/>
@@ -5742,33 +6621,504 @@
           <a:bodyPr wrap="square" lIns="0" tIns="0" rIns="0" bIns="0" rtlCol="0" anchor="ctr"/>
           <a:lstStyle/>
           <a:p>
-            <a:pPr indent="0" marL="0">
-              <a:buNone/>
-            </a:pPr>
-            <a:r>
-              <a:rPr lang="en-US" sz="3800" dirty="0">
-                <a:solidFill>
-                  <a:srgbClr val="24313F"/>
+            <a:pPr algn="ctr" indent="0" marL="0">
+              <a:buNone/>
+            </a:pPr>
+            <a:r>
+              <a:rPr lang="en-US" sz="1550" dirty="0">
+                <a:solidFill>
+                  <a:srgbClr val="4A6B5D"/>
                 </a:solidFill>
                 <a:latin typeface="Georgia" pitchFamily="34" charset="0"/>
                 <a:ea typeface="Georgia" pitchFamily="34" charset="-122"/>
                 <a:cs typeface="Georgia" pitchFamily="34" charset="-120"/>
               </a:rPr>
-              <a:t>A shortcut with a beneficiary</a:t>
-            </a:r>
-            <a:endParaRPr lang="en-US" sz="3800" dirty="0"/>
-          </a:p>
-        </p:txBody>
-      </p:sp>
-      <p:sp>
-        <p:nvSpPr>
-          <p:cNvPr id="6" name="Shape 4"/>
-          <p:cNvSpPr/>
-          <p:nvPr/>
-        </p:nvSpPr>
-        <p:spPr>
-          <a:xfrm>
-            <a:off x="822960" y="2514600"/>
+              <a:t>The house</a:t>
+            </a:r>
+            <a:endParaRPr lang="en-US" sz="1550" dirty="0"/>
+          </a:p>
+        </p:txBody>
+      </p:sp>
+      <p:sp>
+        <p:nvSpPr>
+          <p:cNvPr id="8" name="Text 5"/>
+          <p:cNvSpPr/>
+          <p:nvPr/>
+        </p:nvSpPr>
+        <p:spPr>
+          <a:xfrm>
+            <a:off x="822960" y="3886200"/>
+            <a:ext cx="2361438" cy="548640"/>
+          </a:xfrm>
+          <a:prstGeom prst="rect">
+            <a:avLst/>
+          </a:prstGeom>
+          <a:noFill/>
+          <a:ln/>
+        </p:spPr>
+        <p:txBody>
+          <a:bodyPr wrap="square" lIns="0" tIns="0" rIns="0" bIns="0" rtlCol="0" anchor="t"/>
+          <a:lstStyle/>
+          <a:p>
+            <a:pPr algn="ctr" indent="0" marL="0">
+              <a:lnSpc>
+                <a:spcPts val="1300"/>
+              </a:lnSpc>
+              <a:buNone/>
+            </a:pPr>
+            <a:r>
+              <a:rPr lang="en-US" sz="1050" i="1" dirty="0">
+                <a:solidFill>
+                  <a:srgbClr val="7A7F72"/>
+                </a:solidFill>
+                <a:latin typeface="Arial" pitchFamily="34" charset="0"/>
+                <a:ea typeface="Arial" pitchFamily="34" charset="-122"/>
+                <a:cs typeface="Arial" pitchFamily="34" charset="-120"/>
+              </a:rPr>
+              <a:t>heritage as the establishing shot</a:t>
+            </a:r>
+            <a:endParaRPr lang="en-US" sz="1050" dirty="0"/>
+          </a:p>
+        </p:txBody>
+      </p:sp>
+      <p:sp>
+        <p:nvSpPr>
+          <p:cNvPr id="9" name="Shape 6"/>
+          <p:cNvSpPr/>
+          <p:nvPr/>
+        </p:nvSpPr>
+        <p:spPr>
+          <a:xfrm>
+            <a:off x="3550158" y="1143000"/>
+            <a:ext cx="2361438" cy="2377440"/>
+          </a:xfrm>
+          <a:prstGeom prst="rect">
+            <a:avLst/>
+          </a:prstGeom>
+          <a:solidFill>
+            <a:srgbClr val="FAF8F1"/>
+          </a:solidFill>
+          <a:ln w="9525">
+            <a:solidFill>
+              <a:srgbClr val="D9D4C4"/>
+            </a:solidFill>
+            <a:prstDash val="solid"/>
+          </a:ln>
+        </p:spPr>
+      </p:sp>
+      <p:pic>
+        <p:nvPicPr>
+          <p:cNvPr id="10" name="Image 1" descr="/Users/dogan/Documents/Vaults/Courses/wiki/classes/media-studies/decks/_build/img/downton-dining.jpg">    </p:cNvPr>
+          <p:cNvPicPr>
+            <a:picLocks noChangeAspect="1"/>
+          </p:cNvPicPr>
+          <p:nvPr/>
+        </p:nvPicPr>
+        <p:blipFill>
+          <a:blip r:embed="rId2"/>
+          <a:stretch>
+            <a:fillRect/>
+          </a:stretch>
+        </p:blipFill>
+        <p:spPr>
+          <a:xfrm>
+            <a:off x="3623310" y="1771675"/>
+            <a:ext cx="2215134" cy="1120090"/>
+          </a:xfrm>
+          <a:prstGeom prst="rect">
+            <a:avLst/>
+          </a:prstGeom>
+        </p:spPr>
+      </p:pic>
+      <p:sp>
+        <p:nvSpPr>
+          <p:cNvPr id="11" name="Text 7"/>
+          <p:cNvSpPr/>
+          <p:nvPr/>
+        </p:nvSpPr>
+        <p:spPr>
+          <a:xfrm>
+            <a:off x="3550158" y="3566160"/>
+            <a:ext cx="2361438" cy="320040"/>
+          </a:xfrm>
+          <a:prstGeom prst="rect">
+            <a:avLst/>
+          </a:prstGeom>
+          <a:noFill/>
+          <a:ln/>
+        </p:spPr>
+        <p:txBody>
+          <a:bodyPr wrap="square" lIns="0" tIns="0" rIns="0" bIns="0" rtlCol="0" anchor="ctr"/>
+          <a:lstStyle/>
+          <a:p>
+            <a:pPr algn="ctr" indent="0" marL="0">
+              <a:buNone/>
+            </a:pPr>
+            <a:r>
+              <a:rPr lang="en-US" sz="1550" dirty="0">
+                <a:solidFill>
+                  <a:srgbClr val="4A6B5D"/>
+                </a:solidFill>
+                <a:latin typeface="Georgia" pitchFamily="34" charset="0"/>
+                <a:ea typeface="Georgia" pitchFamily="34" charset="-122"/>
+                <a:cs typeface="Georgia" pitchFamily="34" charset="-120"/>
+              </a:rPr>
+              <a:t>The dinner</a:t>
+            </a:r>
+            <a:endParaRPr lang="en-US" sz="1550" dirty="0"/>
+          </a:p>
+        </p:txBody>
+      </p:sp>
+      <p:sp>
+        <p:nvSpPr>
+          <p:cNvPr id="12" name="Text 8"/>
+          <p:cNvSpPr/>
+          <p:nvPr/>
+        </p:nvSpPr>
+        <p:spPr>
+          <a:xfrm>
+            <a:off x="3550158" y="3886200"/>
+            <a:ext cx="2361438" cy="548640"/>
+          </a:xfrm>
+          <a:prstGeom prst="rect">
+            <a:avLst/>
+          </a:prstGeom>
+          <a:noFill/>
+          <a:ln/>
+        </p:spPr>
+        <p:txBody>
+          <a:bodyPr wrap="square" lIns="0" tIns="0" rIns="0" bIns="0" rtlCol="0" anchor="t"/>
+          <a:lstStyle/>
+          <a:p>
+            <a:pPr algn="ctr" indent="0" marL="0">
+              <a:lnSpc>
+                <a:spcPts val="1300"/>
+              </a:lnSpc>
+              <a:buNone/>
+            </a:pPr>
+            <a:r>
+              <a:rPr lang="en-US" sz="1050" i="1" dirty="0">
+                <a:solidFill>
+                  <a:srgbClr val="7A7F72"/>
+                </a:solidFill>
+                <a:latin typeface="Arial" pitchFamily="34" charset="0"/>
+                <a:ea typeface="Arial" pitchFamily="34" charset="-122"/>
+                <a:cs typeface="Arial" pitchFamily="34" charset="-120"/>
+              </a:rPr>
+              <a:t>order, ritual, everyone in place</a:t>
+            </a:r>
+            <a:endParaRPr lang="en-US" sz="1050" dirty="0"/>
+          </a:p>
+        </p:txBody>
+      </p:sp>
+      <p:sp>
+        <p:nvSpPr>
+          <p:cNvPr id="13" name="Shape 9"/>
+          <p:cNvSpPr/>
+          <p:nvPr/>
+        </p:nvSpPr>
+        <p:spPr>
+          <a:xfrm>
+            <a:off x="6277356" y="1143000"/>
+            <a:ext cx="2361438" cy="2377440"/>
+          </a:xfrm>
+          <a:prstGeom prst="rect">
+            <a:avLst/>
+          </a:prstGeom>
+          <a:solidFill>
+            <a:srgbClr val="FAF8F1"/>
+          </a:solidFill>
+          <a:ln w="9525">
+            <a:solidFill>
+              <a:srgbClr val="D9D4C4"/>
+            </a:solidFill>
+            <a:prstDash val="solid"/>
+          </a:ln>
+        </p:spPr>
+      </p:sp>
+      <p:pic>
+        <p:nvPicPr>
+          <p:cNvPr id="14" name="Image 2" descr="/Users/dogan/Documents/Vaults/Courses/wiki/classes/media-studies/decks/_build/img/downton-servants.jpg">    </p:cNvPr>
+          <p:cNvPicPr>
+            <a:picLocks noChangeAspect="1"/>
+          </p:cNvPicPr>
+          <p:nvPr/>
+        </p:nvPicPr>
+        <p:blipFill>
+          <a:blip r:embed="rId3"/>
+          <a:stretch>
+            <a:fillRect/>
+          </a:stretch>
+        </p:blipFill>
+        <p:spPr>
+          <a:xfrm>
+            <a:off x="6350508" y="1708714"/>
+            <a:ext cx="2215134" cy="1246013"/>
+          </a:xfrm>
+          <a:prstGeom prst="rect">
+            <a:avLst/>
+          </a:prstGeom>
+        </p:spPr>
+      </p:pic>
+      <p:sp>
+        <p:nvSpPr>
+          <p:cNvPr id="15" name="Text 10"/>
+          <p:cNvSpPr/>
+          <p:nvPr/>
+        </p:nvSpPr>
+        <p:spPr>
+          <a:xfrm>
+            <a:off x="6277356" y="3566160"/>
+            <a:ext cx="2361438" cy="320040"/>
+          </a:xfrm>
+          <a:prstGeom prst="rect">
+            <a:avLst/>
+          </a:prstGeom>
+          <a:noFill/>
+          <a:ln/>
+        </p:spPr>
+        <p:txBody>
+          <a:bodyPr wrap="square" lIns="0" tIns="0" rIns="0" bIns="0" rtlCol="0" anchor="ctr"/>
+          <a:lstStyle/>
+          <a:p>
+            <a:pPr algn="ctr" indent="0" marL="0">
+              <a:buNone/>
+            </a:pPr>
+            <a:r>
+              <a:rPr lang="en-US" sz="1550" dirty="0">
+                <a:solidFill>
+                  <a:srgbClr val="4A6B5D"/>
+                </a:solidFill>
+                <a:latin typeface="Georgia" pitchFamily="34" charset="0"/>
+                <a:ea typeface="Georgia" pitchFamily="34" charset="-122"/>
+                <a:cs typeface="Georgia" pitchFamily="34" charset="-120"/>
+              </a:rPr>
+              <a:t>Below stairs</a:t>
+            </a:r>
+            <a:endParaRPr lang="en-US" sz="1550" dirty="0"/>
+          </a:p>
+        </p:txBody>
+      </p:sp>
+      <p:sp>
+        <p:nvSpPr>
+          <p:cNvPr id="16" name="Text 11"/>
+          <p:cNvSpPr/>
+          <p:nvPr/>
+        </p:nvSpPr>
+        <p:spPr>
+          <a:xfrm>
+            <a:off x="6277356" y="3886200"/>
+            <a:ext cx="2361438" cy="548640"/>
+          </a:xfrm>
+          <a:prstGeom prst="rect">
+            <a:avLst/>
+          </a:prstGeom>
+          <a:noFill/>
+          <a:ln/>
+        </p:spPr>
+        <p:txBody>
+          <a:bodyPr wrap="square" lIns="0" tIns="0" rIns="0" bIns="0" rtlCol="0" anchor="t"/>
+          <a:lstStyle/>
+          <a:p>
+            <a:pPr algn="ctr" indent="0" marL="0">
+              <a:lnSpc>
+                <a:spcPts val="1300"/>
+              </a:lnSpc>
+              <a:buNone/>
+            </a:pPr>
+            <a:r>
+              <a:rPr lang="en-US" sz="1050" i="1" dirty="0">
+                <a:solidFill>
+                  <a:srgbClr val="7A7F72"/>
+                </a:solidFill>
+                <a:latin typeface="Arial" pitchFamily="34" charset="0"/>
+                <a:ea typeface="Arial" pitchFamily="34" charset="-122"/>
+                <a:cs typeface="Arial" pitchFamily="34" charset="-120"/>
+              </a:rPr>
+              <a:t>labor, visible but ranked</a:t>
+            </a:r>
+            <a:endParaRPr lang="en-US" sz="1050" dirty="0"/>
+          </a:p>
+        </p:txBody>
+      </p:sp>
+      <p:sp>
+        <p:nvSpPr>
+          <p:cNvPr id="17" name="Shape 12"/>
+          <p:cNvSpPr/>
+          <p:nvPr/>
+        </p:nvSpPr>
+        <p:spPr>
+          <a:xfrm>
+            <a:off x="9004554" y="1143000"/>
+            <a:ext cx="2361438" cy="2377440"/>
+          </a:xfrm>
+          <a:prstGeom prst="rect">
+            <a:avLst/>
+          </a:prstGeom>
+          <a:solidFill>
+            <a:srgbClr val="FAF8F1"/>
+          </a:solidFill>
+          <a:ln w="9525">
+            <a:solidFill>
+              <a:srgbClr val="D9D4C4"/>
+            </a:solidFill>
+            <a:prstDash val="solid"/>
+          </a:ln>
+        </p:spPr>
+      </p:sp>
+      <p:pic>
+        <p:nvPicPr>
+          <p:cNvPr id="18" name="Image 3" descr="/Users/dogan/Documents/Vaults/Courses/wiki/classes/media-studies/decks/_build/img/downton-village.jpg">    </p:cNvPr>
+          <p:cNvPicPr>
+            <a:picLocks noChangeAspect="1"/>
+          </p:cNvPicPr>
+          <p:nvPr/>
+        </p:nvPicPr>
+        <p:blipFill>
+          <a:blip r:embed="rId4"/>
+          <a:stretch>
+            <a:fillRect/>
+          </a:stretch>
+        </p:blipFill>
+        <p:spPr>
+          <a:xfrm>
+            <a:off x="9077706" y="1708714"/>
+            <a:ext cx="2215134" cy="1246013"/>
+          </a:xfrm>
+          <a:prstGeom prst="rect">
+            <a:avLst/>
+          </a:prstGeom>
+        </p:spPr>
+      </p:pic>
+      <p:sp>
+        <p:nvSpPr>
+          <p:cNvPr id="19" name="Text 13"/>
+          <p:cNvSpPr/>
+          <p:nvPr/>
+        </p:nvSpPr>
+        <p:spPr>
+          <a:xfrm>
+            <a:off x="9004554" y="3566160"/>
+            <a:ext cx="2361438" cy="320040"/>
+          </a:xfrm>
+          <a:prstGeom prst="rect">
+            <a:avLst/>
+          </a:prstGeom>
+          <a:noFill/>
+          <a:ln/>
+        </p:spPr>
+        <p:txBody>
+          <a:bodyPr wrap="square" lIns="0" tIns="0" rIns="0" bIns="0" rtlCol="0" anchor="ctr"/>
+          <a:lstStyle/>
+          <a:p>
+            <a:pPr algn="ctr" indent="0" marL="0">
+              <a:buNone/>
+            </a:pPr>
+            <a:r>
+              <a:rPr lang="en-US" sz="1550" dirty="0">
+                <a:solidFill>
+                  <a:srgbClr val="4A6B5D"/>
+                </a:solidFill>
+                <a:latin typeface="Georgia" pitchFamily="34" charset="0"/>
+                <a:ea typeface="Georgia" pitchFamily="34" charset="-122"/>
+                <a:cs typeface="Georgia" pitchFamily="34" charset="-120"/>
+              </a:rPr>
+              <a:t>The village</a:t>
+            </a:r>
+            <a:endParaRPr lang="en-US" sz="1550" dirty="0"/>
+          </a:p>
+        </p:txBody>
+      </p:sp>
+      <p:sp>
+        <p:nvSpPr>
+          <p:cNvPr id="20" name="Text 14"/>
+          <p:cNvSpPr/>
+          <p:nvPr/>
+        </p:nvSpPr>
+        <p:spPr>
+          <a:xfrm>
+            <a:off x="9004554" y="3886200"/>
+            <a:ext cx="2361438" cy="548640"/>
+          </a:xfrm>
+          <a:prstGeom prst="rect">
+            <a:avLst/>
+          </a:prstGeom>
+          <a:noFill/>
+          <a:ln/>
+        </p:spPr>
+        <p:txBody>
+          <a:bodyPr wrap="square" lIns="0" tIns="0" rIns="0" bIns="0" rtlCol="0" anchor="t"/>
+          <a:lstStyle/>
+          <a:p>
+            <a:pPr algn="ctr" indent="0" marL="0">
+              <a:lnSpc>
+                <a:spcPts val="1300"/>
+              </a:lnSpc>
+              <a:buNone/>
+            </a:pPr>
+            <a:r>
+              <a:rPr lang="en-US" sz="1050" i="1" dirty="0">
+                <a:solidFill>
+                  <a:srgbClr val="7A7F72"/>
+                </a:solidFill>
+                <a:latin typeface="Arial" pitchFamily="34" charset="0"/>
+                <a:ea typeface="Arial" pitchFamily="34" charset="-122"/>
+                <a:cs typeface="Arial" pitchFamily="34" charset="-120"/>
+              </a:rPr>
+              <a:t>a nation with no cities in it</a:t>
+            </a:r>
+            <a:endParaRPr lang="en-US" sz="1050" dirty="0"/>
+          </a:p>
+        </p:txBody>
+      </p:sp>
+      <p:sp>
+        <p:nvSpPr>
+          <p:cNvPr id="21" name="Text 15"/>
+          <p:cNvSpPr/>
+          <p:nvPr/>
+        </p:nvSpPr>
+        <p:spPr>
+          <a:xfrm>
+            <a:off x="822960" y="4526280"/>
+            <a:ext cx="10543032" cy="274320"/>
+          </a:xfrm>
+          <a:prstGeom prst="rect">
+            <a:avLst/>
+          </a:prstGeom>
+          <a:noFill/>
+          <a:ln/>
+        </p:spPr>
+        <p:txBody>
+          <a:bodyPr wrap="square" lIns="0" tIns="0" rIns="0" bIns="0" rtlCol="0" anchor="ctr"/>
+          <a:lstStyle/>
+          <a:p>
+            <a:pPr algn="ctr" indent="0" marL="0">
+              <a:buNone/>
+            </a:pPr>
+            <a:r>
+              <a:rPr lang="en-US" sz="1000" dirty="0">
+                <a:solidFill>
+                  <a:srgbClr val="7A7F72"/>
+                </a:solidFill>
+                <a:latin typeface="Arial" pitchFamily="34" charset="0"/>
+                <a:ea typeface="Arial" pitchFamily="34" charset="-122"/>
+                <a:cs typeface="Arial" pitchFamily="34" charset="-120"/>
+              </a:rPr>
+              <a:t>Downton Abbey (ITV, 2010 to 2015). The Britain brand, selected for global audiences</a:t>
+            </a:r>
+            <a:endParaRPr lang="en-US" sz="1000" dirty="0"/>
+          </a:p>
+        </p:txBody>
+      </p:sp>
+      <p:sp>
+        <p:nvSpPr>
+          <p:cNvPr id="22" name="Shape 16"/>
+          <p:cNvSpPr/>
+          <p:nvPr/>
+        </p:nvSpPr>
+        <p:spPr>
+          <a:xfrm>
+            <a:off x="822960" y="4983480"/>
             <a:ext cx="914400" cy="0"/>
           </a:xfrm>
           <a:prstGeom prst="line">
@@ -5785,14 +7135,14 @@
       </p:sp>
       <p:sp>
         <p:nvSpPr>
-          <p:cNvPr id="7" name="Text 5"/>
-          <p:cNvSpPr/>
-          <p:nvPr/>
-        </p:nvSpPr>
-        <p:spPr>
-          <a:xfrm>
-            <a:off x="822960" y="2743200"/>
-            <a:ext cx="9875520" cy="2103120"/>
+          <p:cNvPr id="23" name="Text 17"/>
+          <p:cNvSpPr/>
+          <p:nvPr/>
+        </p:nvSpPr>
+        <p:spPr>
+          <a:xfrm>
+            <a:off x="822960" y="5120640"/>
+            <a:ext cx="10543032" cy="685800"/>
           </a:xfrm>
           <a:prstGeom prst="rect">
             <a:avLst/>
@@ -5806,28 +7156,28 @@
           <a:p>
             <a:pPr indent="0" marL="0">
               <a:lnSpc>
-                <a:spcPts val="2800"/>
+                <a:spcPts val="1800"/>
               </a:lnSpc>
               <a:buNone/>
             </a:pPr>
             <a:r>
-              <a:rPr lang="en-US" sz="2000" dirty="0">
-                <a:solidFill>
-                  <a:srgbClr val="24313F"/>
+              <a:rPr lang="en-US" sz="1350" i="1" dirty="0">
+                <a:solidFill>
+                  <a:srgbClr val="4A6B5D"/>
                 </a:solidFill>
                 <a:latin typeface="Georgia" pitchFamily="34" charset="0"/>
                 <a:ea typeface="Georgia" pitchFamily="34" charset="-122"/>
                 <a:cs typeface="Georgia" pitchFamily="34" charset="-120"/>
               </a:rPr>
-              <a:t>A stereotype is not a lie. It is a shortcut, and every shortcut has a beneficiary and someone who pays the toll. Ask both questions of every case: who is served by this being the quick version, and who is cost by it? A counter-stereotype, like Carl in UP, registers as surprising only because the shortcut is so well worn.</a:t>
-            </a:r>
-            <a:endParaRPr lang="en-US" sz="2000" dirty="0"/>
-          </a:p>
-        </p:txBody>
-      </p:sp>
-      <p:sp>
-        <p:nvSpPr>
-          <p:cNvPr id="8" name="Shape 6"/>
+              <a:t>Every cell is a selection, and every selection leaves something out: ask of each what a viewer in another country concludes Britain is, and what had to vanish for that conclusion to hold. Then the closer, spoken only: what would a China brand select, and omit?</a:t>
+            </a:r>
+            <a:endParaRPr lang="en-US" sz="1350" dirty="0"/>
+          </a:p>
+        </p:txBody>
+      </p:sp>
+      <p:sp>
+        <p:nvSpPr>
+          <p:cNvPr id="24" name="Shape 18"/>
           <p:cNvSpPr/>
           <p:nvPr/>
         </p:nvSpPr>
@@ -5850,7 +7200,7 @@
       </p:sp>
       <p:sp>
         <p:nvSpPr>
-          <p:cNvPr id="9" name="Text 7"/>
+          <p:cNvPr id="25" name="Text 19"/>
           <p:cNvSpPr/>
           <p:nvPr/>
         </p:nvSpPr>
@@ -5889,7 +7239,7 @@
       </p:sp>
       <p:sp>
         <p:nvSpPr>
-          <p:cNvPr id="10" name="Text 8"/>
+          <p:cNvPr id="26" name="Text 20"/>
           <p:cNvSpPr/>
           <p:nvPr/>
         </p:nvSpPr>

</xml_diff>